<commit_message>
Deck: remove persona names, show mentor specializations instead
</commit_message>
<xml_diff>
--- a/deck/Colony-AI-Deck.pptx
+++ b/deck/Colony-AI-Deck.pptx
@@ -4310,7 +4310,7 @@
                 <a:ea typeface="Arial" pitchFamily="34" charset="-122"/>
                 <a:cs typeface="Arial" pitchFamily="34" charset="-120"/>
               </a:rPr>
-              <a:t>GABI</a:t>
+              <a:t>20 MENTORS</a:t>
             </a:r>
             <a:endParaRPr lang="en-US" sz="3000" dirty="0"/>
           </a:p>
@@ -4349,7 +4349,7 @@
                 <a:ea typeface="Arial" pitchFamily="34" charset="-122"/>
                 <a:cs typeface="Arial" pitchFamily="34" charset="-120"/>
               </a:rPr>
-              <a:t>Flagship mentor — live sessions today</a:t>
+              <a:t>Specialized mentors — live in the fleet today</a:t>
             </a:r>
             <a:endParaRPr lang="en-US" sz="1350" dirty="0"/>
           </a:p>
@@ -4364,7 +4364,7 @@
         <p:spPr>
           <a:xfrm>
             <a:off x="7543800" y="2907792"/>
-            <a:ext cx="2651760" cy="329184"/>
+            <a:ext cx="3291840" cy="329184"/>
           </a:xfrm>
           <a:prstGeom prst="roundRect">
             <a:avLst>
@@ -4391,7 +4391,7 @@
         <p:spPr>
           <a:xfrm>
             <a:off x="7543800" y="2907792"/>
-            <a:ext cx="2651760" cy="329184"/>
+            <a:ext cx="3291840" cy="329184"/>
           </a:xfrm>
           <a:prstGeom prst="rect">
             <a:avLst/>
@@ -4415,7 +4415,7 @@
                 <a:ea typeface="Arial" pitchFamily="34" charset="-122"/>
                 <a:cs typeface="Arial" pitchFamily="34" charset="-120"/>
               </a:rPr>
-              <a:t>REMEMBERS EVERY STUDENT</a:t>
+              <a:t>MEMORY · GOVERNANCE · RECEIPTS</a:t>
             </a:r>
             <a:endParaRPr lang="en-US" sz="1200" dirty="0"/>
           </a:p>
@@ -4454,7 +4454,7 @@
                 <a:ea typeface="Arial" pitchFamily="34" charset="-122"/>
                 <a:cs typeface="Arial" pitchFamily="34" charset="-120"/>
               </a:rPr>
-              <a:t>THE MENTOR FLEET</a:t>
+              <a:t>SPECIALIZATIONS</a:t>
             </a:r>
             <a:endParaRPr lang="en-US" sz="1200" dirty="0"/>
           </a:p>
@@ -4520,7 +4520,7 @@
                 <a:ea typeface="Arial" pitchFamily="34" charset="-122"/>
                 <a:cs typeface="Arial" pitchFamily="34" charset="-120"/>
               </a:rPr>
-              <a:t>Tim</a:t>
+              <a:t>Drawing &amp; body</a:t>
             </a:r>
             <a:endParaRPr lang="en-US" sz="1250" dirty="0"/>
           </a:p>
@@ -4586,7 +4586,7 @@
                 <a:ea typeface="Arial" pitchFamily="34" charset="-122"/>
                 <a:cs typeface="Arial" pitchFamily="34" charset="-120"/>
               </a:rPr>
-              <a:t>Maya</a:t>
+              <a:t>Aesthetics &amp; UX</a:t>
             </a:r>
             <a:endParaRPr lang="en-US" sz="1250" dirty="0"/>
           </a:p>
@@ -4652,7 +4652,7 @@
                 <a:ea typeface="Arial" pitchFamily="34" charset="-122"/>
                 <a:cs typeface="Arial" pitchFamily="34" charset="-120"/>
               </a:rPr>
-              <a:t>Stas</a:t>
+              <a:t>Engineering</a:t>
             </a:r>
             <a:endParaRPr lang="en-US" sz="1250" dirty="0"/>
           </a:p>
@@ -4718,7 +4718,7 @@
                 <a:ea typeface="Arial" pitchFamily="34" charset="-122"/>
                 <a:cs typeface="Arial" pitchFamily="34" charset="-120"/>
               </a:rPr>
-              <a:t>Dreamweaver</a:t>
+              <a:t>Storytelling</a:t>
             </a:r>
             <a:endParaRPr lang="en-US" sz="1250" dirty="0"/>
           </a:p>
@@ -4784,7 +4784,7 @@
                 <a:ea typeface="Arial" pitchFamily="34" charset="-122"/>
                 <a:cs typeface="Arial" pitchFamily="34" charset="-120"/>
               </a:rPr>
-              <a:t>Storyteller</a:t>
+              <a:t>Game copilot</a:t>
             </a:r>
             <a:endParaRPr lang="en-US" sz="1250" dirty="0"/>
           </a:p>
@@ -4850,7 +4850,7 @@
                 <a:ea typeface="Arial" pitchFamily="34" charset="-122"/>
                 <a:cs typeface="Arial" pitchFamily="34" charset="-120"/>
               </a:rPr>
-              <a:t>Nathan Gold</a:t>
+              <a:t>Knowledge</a:t>
             </a:r>
             <a:endParaRPr lang="en-US" sz="1250" dirty="0"/>
           </a:p>
@@ -4889,7 +4889,7 @@
                 <a:ea typeface="Arial" pitchFamily="34" charset="-122"/>
                 <a:cs typeface="Arial" pitchFamily="34" charset="-120"/>
               </a:rPr>
-              <a:t>Mentor personas are registered assistants in the live fleet — not mockups.</a:t>
+              <a:t>Every mentor is a registered assistant in the live fleet — running today, not mocked up.</a:t>
             </a:r>
             <a:endParaRPr lang="en-US" sz="1200" dirty="0"/>
           </a:p>

</xml_diff>

<commit_message>
Deck: public repo links, add go-mentor live tile and LLM-as-judge evals
</commit_message>
<xml_diff>
--- a/deck/Colony-AI-Deck.pptx
+++ b/deck/Colony-AI-Deck.pptx
@@ -2360,7 +2360,7 @@
                 <a:ea typeface="Arial" pitchFamily="34" charset="-122"/>
                 <a:cs typeface="Arial" pitchFamily="34" charset="-120"/>
               </a:rPr>
-              <a:t>Valentin Kalinin, founder   ·   valentin@mind.glass   ·   github.com/tdesc/atma   ·   Saint Petersburg</a:t>
+              <a:t>Valentin Kalinin, founder   ·   valentin@mind.glass   ·   github.com/tdesc/colony-ai-deck   ·   Saint Petersburg</a:t>
             </a:r>
             <a:endParaRPr lang="en-US" sz="1300" dirty="0"/>
           </a:p>
@@ -6163,17 +6163,17 @@
               <a:buNone/>
             </a:pPr>
             <a:r>
-              <a:rPr lang="en-US" sz="5800" b="1" dirty="0">
-                <a:solidFill>
-                  <a:srgbClr val="0B5D66"/>
-                </a:solidFill>
-                <a:latin typeface="Arial" pitchFamily="34" charset="0"/>
-                <a:ea typeface="Arial" pitchFamily="34" charset="-122"/>
-                <a:cs typeface="Arial" pitchFamily="34" charset="-120"/>
-              </a:rPr>
-              <a:t>:9090</a:t>
-            </a:r>
-            <a:endParaRPr lang="en-US" sz="5800" dirty="0"/>
+              <a:rPr lang="en-US" sz="3400" b="1" dirty="0">
+                <a:solidFill>
+                  <a:srgbClr val="D97706"/>
+                </a:solidFill>
+                <a:latin typeface="Arial" pitchFamily="34" charset="0"/>
+                <a:ea typeface="Arial" pitchFamily="34" charset="-122"/>
+                <a:cs typeface="Arial" pitchFamily="34" charset="-120"/>
+              </a:rPr>
+              <a:t>go-mentor</a:t>
+            </a:r>
+            <a:endParaRPr lang="en-US" sz="3400" dirty="0"/>
           </a:p>
         </p:txBody>
       </p:sp>
@@ -6210,7 +6210,7 @@
                 <a:ea typeface="Arial" pitchFamily="34" charset="-122"/>
                 <a:cs typeface="Arial" pitchFamily="34" charset="-120"/>
               </a:rPr>
-              <a:t>orchestrator ready</a:t>
+              <a:t>coding mentor, live</a:t>
             </a:r>
             <a:endParaRPr lang="en-US" sz="1450" dirty="0"/>
           </a:p>
@@ -6249,7 +6249,7 @@
                 <a:ea typeface="Arial" pitchFamily="34" charset="-122"/>
                 <a:cs typeface="Arial" pitchFamily="34" charset="-120"/>
               </a:rPr>
-              <a:t>ready_for_programs — canary passed</a:t>
+              <a:t>go-mentor.mind.glass — goals → verified outcomes</a:t>
             </a:r>
             <a:endParaRPr lang="en-US" sz="1200" dirty="0"/>
           </a:p>
@@ -6375,7 +6375,7 @@
                 <a:ea typeface="Arial" pitchFamily="34" charset="-122"/>
                 <a:cs typeface="Arial" pitchFamily="34" charset="-120"/>
               </a:rPr>
-              <a:t>Langfuse traces · Temporal workflows · OpenTelemetry · Centrifugo realtime · local MLX model gateway</a:t>
+              <a:t>Langfuse traces · Temporal workflows · OpenTelemetry · Centrifugo realtime · local MLX model gateway · LLM-as-judge evals</a:t>
             </a:r>
             <a:endParaRPr lang="en-US" sz="1300" dirty="0"/>
           </a:p>
@@ -8264,7 +8264,7 @@
                 <a:ea typeface="Arial" pitchFamily="34" charset="-122"/>
                 <a:cs typeface="Arial" pitchFamily="34" charset="-120"/>
               </a:rPr>
-              <a:t>github.com/tdesc/atma</a:t>
+              <a:t>github.com/tdesc/colony-ai-deck</a:t>
             </a:r>
             <a:endParaRPr lang="en-US" sz="1800" dirty="0"/>
           </a:p>

</xml_diff>

<commit_message>
Deck: who/do/how tagline, story-first problem slide, drop :9090 noise
</commit_message>
<xml_diff>
--- a/deck/Colony-AI-Deck.pptx
+++ b/deck/Colony-AI-Deck.pptx
@@ -2259,7 +2259,7 @@
                 <a:ea typeface="Arial" pitchFamily="34" charset="-122"/>
                 <a:cs typeface="Arial" pitchFamily="34" charset="-120"/>
               </a:rPr>
-              <a:t>AI agents that remember, govern themselves, and prove what they did.</a:t>
+              <a:t>for students and small teams: AI mentors that remember them and prove what they did.</a:t>
             </a:r>
             <a:endParaRPr lang="en-US" sz="1800" dirty="0"/>
           </a:p>
@@ -2298,7 +2298,7 @@
                 <a:ea typeface="Arial" pitchFamily="34" charset="-122"/>
                 <a:cs typeface="Arial" pitchFamily="34" charset="-120"/>
               </a:rPr>
-              <a:t>44 containers running right now  ·  orchestrator :9090  ·  467K memory vectors  ·  Society Protocol with receipts</a:t>
+              <a:t>44 containers running right now  ·  467K memory vectors  ·  Society Protocol with receipts</a:t>
             </a:r>
             <a:endParaRPr lang="en-US" sz="1350" dirty="0"/>
           </a:p>
@@ -2536,7 +2536,7 @@
                 <a:ea typeface="Arial" pitchFamily="34" charset="-122"/>
                 <a:cs typeface="Arial" pitchFamily="34" charset="-120"/>
               </a:rPr>
-              <a:t>LLM agents wake up with no past and no rules.</a:t>
+              <a:t>Tuesday. The mentor asks her name again.</a:t>
             </a:r>
             <a:endParaRPr lang="en-US" sz="3000" dirty="0"/>
           </a:p>
@@ -2551,7 +2551,7 @@
         <p:spPr>
           <a:xfrm>
             <a:off x="548640" y="1389888"/>
-            <a:ext cx="10424160" cy="365760"/>
+            <a:ext cx="10424160" cy="685800"/>
           </a:xfrm>
           <a:prstGeom prst="rect">
             <a:avLst/>
@@ -2575,7 +2575,7 @@
                 <a:ea typeface="Arial" pitchFamily="34" charset="-122"/>
                 <a:cs typeface="Arial" pitchFamily="34" charset="-120"/>
               </a:rPr>
-              <a:t>Anyone can spawn a hundred agents in 2026. Almost nobody can govern them — or trust what they claim.</a:t>
+              <a:t>She trained with it all Monday. At midnight the session died — and with it every memory of her. That is every AI agent in 2026.</a:t>
             </a:r>
             <a:endParaRPr lang="en-US" sz="1500" dirty="0"/>
           </a:p>
@@ -3424,7 +3424,7 @@
                 <a:ea typeface="Arial" pitchFamily="34" charset="-122"/>
                 <a:cs typeface="Arial" pitchFamily="34" charset="-120"/>
               </a:rPr>
-              <a:t>Orchestrator :9090</a:t>
+              <a:t>Job governance</a:t>
             </a:r>
             <a:endParaRPr lang="en-US" sz="1450" dirty="0"/>
           </a:p>
@@ -6414,7 +6414,7 @@
                 <a:ea typeface="Arial" pitchFamily="34" charset="-122"/>
                 <a:cs typeface="Arial" pitchFamily="34" charset="-120"/>
               </a:rPr>
-              <a:t>Source: live docker ps and GET :9090/readyz on the founder's machine, 2026-10-21. Numbers are observed, not aspirational.</a:t>
+              <a:t>Source: live docker ps and readiness checks on the founder's machine, 2026-10-21. Numbers are observed, not aspirational.</a:t>
             </a:r>
             <a:endParaRPr lang="en-US" sz="1200" dirty="0"/>
           </a:p>

</xml_diff>

<commit_message>
Deck rev 3: story-first cover with live receipt, artifacts slide, specific cloud ask
</commit_message>
<xml_diff>
--- a/deck/Colony-AI-Deck.pptx
+++ b/deck/Colony-AI-Deck.pptx
@@ -14,9 +14,10 @@
     <p:sldId id="262" r:id="rId8"/>
     <p:sldId id="263" r:id="rId9"/>
     <p:sldId id="264" r:id="rId10"/>
+    <p:sldId id="265" r:id="rId11"/>
   </p:sldIdLst>
   <p:notesMasterIdLst>
-    <p:notesMasterId r:id="rId11"/>
+    <p:notesMasterId r:id="rId12"/>
   </p:notesMasterIdLst>
   <p:sldSz cx="12192000" cy="6858000"/>
   <p:notesSz cx="6858000" cy="12192000"/>
@@ -534,6 +535,94 @@
             <a:fld id="{F7021451-1387-4CA6-816F-3879F97B5CBC}" type="slidenum">
               <a:rPr lang="en-US"/>
               <a:t>1</a:t>
+            </a:fld>
+            <a:endParaRPr lang="en-US"/>
+          </a:p>
+        </p:txBody>
+      </p:sp>
+    </p:spTree>
+    <p:extLst>
+      <p:ext uri="{BB962C8B-B14F-4D97-AF65-F5344CB8AC3E}">
+        <p14:creationId xmlns:p14="http://schemas.microsoft.com/office/powerpoint/2010/main" val="1024086991"/>
+      </p:ext>
+    </p:extLst>
+  </p:cSld>
+  <p:clrMapOvr>
+    <a:masterClrMapping/>
+  </p:clrMapOvr>
+</p:notes>
+</file>
+
+<file path=ppt/notesSlides/notesSlide10.xml><?xml version="1.0" encoding="utf-8"?>
+<p:notes xmlns:a="http://schemas.openxmlformats.org/drawingml/2006/main" xmlns:r="http://schemas.openxmlformats.org/officeDocument/2006/relationships" xmlns:p="http://schemas.openxmlformats.org/presentationml/2006/main">
+  <p:cSld>
+    <p:spTree>
+      <p:nvGrpSpPr>
+        <p:cNvPr id="1" name=""/>
+        <p:cNvGrpSpPr/>
+        <p:nvPr/>
+      </p:nvGrpSpPr>
+      <p:grpSpPr>
+        <a:xfrm>
+          <a:off x="0" y="0"/>
+          <a:ext cx="0" cy="0"/>
+          <a:chOff x="0" y="0"/>
+          <a:chExt cx="0" cy="0"/>
+        </a:xfrm>
+      </p:grpSpPr>
+      <p:sp>
+        <p:nvSpPr>
+          <p:cNvPr id="2" name="Slide Image Placeholder 1"/>
+          <p:cNvSpPr>
+            <a:spLocks noGrp="1" noRot="1" noChangeAspect="1"/>
+          </p:cNvSpPr>
+          <p:nvPr>
+            <p:ph type="sldImg"/>
+          </p:nvPr>
+        </p:nvSpPr>
+        <p:spPr/>
+      </p:sp>
+      <p:sp>
+        <p:nvSpPr>
+          <p:cNvPr id="3" name="Notes Placeholder 2"/>
+          <p:cNvSpPr>
+            <a:spLocks noGrp="1"/>
+          </p:cNvSpPr>
+          <p:nvPr>
+            <p:ph type="body" idx="1"/>
+          </p:nvPr>
+        </p:nvSpPr>
+        <p:spPr/>
+        <p:txBody>
+          <a:bodyPr/>
+          <a:lstStyle/>
+          <a:p>
+            <a:r>
+              <a:rPr lang="en-US" dirty="0"/>
+              <a:t/>
+            </a:r>
+            <a:endParaRPr lang="en-US" dirty="0"/>
+          </a:p>
+        </p:txBody>
+      </p:sp>
+      <p:sp>
+        <p:nvSpPr>
+          <p:cNvPr id="4" name="Slide Number Placeholder 3"/>
+          <p:cNvSpPr>
+            <a:spLocks noGrp="1"/>
+          </p:cNvSpPr>
+          <p:nvPr>
+            <p:ph type="sldNum" sz="quarter" idx="10"/>
+          </p:nvPr>
+        </p:nvSpPr>
+        <p:spPr/>
+        <p:txBody>
+          <a:bodyPr/>
+          <a:lstStyle/>
+          <a:p>
+            <a:fld id="{F7021451-1387-4CA6-816F-3879F97B5CBC}" type="slidenum">
+              <a:rPr lang="en-US"/>
+              <a:t>10</a:t>
             </a:fld>
             <a:endParaRPr lang="en-US"/>
           </a:p>
@@ -2119,7 +2208,7 @@
         </p:nvSpPr>
         <p:spPr>
           <a:xfrm>
-            <a:off x="640080" y="822960"/>
+            <a:off x="640080" y="777240"/>
             <a:ext cx="6400800" cy="320040"/>
           </a:xfrm>
           <a:prstGeom prst="rect">
@@ -2144,7 +2233,7 @@
                 <a:ea typeface="Arial" pitchFamily="34" charset="-122"/>
                 <a:cs typeface="Arial" pitchFamily="34" charset="-120"/>
               </a:rPr>
-              <a:t>COLONY AI  ·  v24.0.0</a:t>
+              <a:t>COLONY AI  ·  MENTOR AS A SERVICE</a:t>
             </a:r>
             <a:endParaRPr lang="en-US" sz="1300" dirty="0"/>
           </a:p>
@@ -2158,8 +2247,8 @@
         </p:nvSpPr>
         <p:spPr>
           <a:xfrm>
-            <a:off x="640080" y="1325880"/>
-            <a:ext cx="7498080" cy="2011680"/>
+            <a:off x="640080" y="1234440"/>
+            <a:ext cx="7680960" cy="1508760"/>
           </a:xfrm>
           <a:prstGeom prst="rect">
             <a:avLst/>
@@ -2173,12 +2262,12 @@
           <a:p>
             <a:pPr indent="0" marL="0">
               <a:lnSpc>
-                <a:spcPts val="6000"/>
+                <a:spcPts val="4600"/>
               </a:lnSpc>
               <a:buNone/>
             </a:pPr>
             <a:r>
-              <a:rPr lang="en-US" sz="5400" b="1" dirty="0">
+              <a:rPr lang="en-US" sz="4000" b="1" dirty="0">
                 <a:solidFill>
                   <a:srgbClr val="FFFFFF"/>
                 </a:solidFill>
@@ -2186,19 +2275,19 @@
                 <a:ea typeface="Arial" pitchFamily="34" charset="-122"/>
                 <a:cs typeface="Arial" pitchFamily="34" charset="-120"/>
               </a:rPr>
-              <a:t>Multi-Agent</a:t>
-            </a:r>
-            <a:endParaRPr lang="en-US" sz="5400" dirty="0"/>
+              <a:t>Tuesday.</a:t>
+            </a:r>
+            <a:endParaRPr lang="en-US" sz="4000" dirty="0"/>
           </a:p>
           <a:p>
             <a:pPr indent="0" marL="0">
               <a:lnSpc>
-                <a:spcPts val="6000"/>
+                <a:spcPts val="4600"/>
               </a:lnSpc>
               <a:buNone/>
             </a:pPr>
             <a:r>
-              <a:rPr lang="en-US" sz="5400" b="1" dirty="0">
+              <a:rPr lang="en-US" sz="4000" b="1" dirty="0">
                 <a:solidFill>
                   <a:srgbClr val="FFFFFF"/>
                 </a:solidFill>
@@ -2206,9 +2295,9 @@
                 <a:ea typeface="Arial" pitchFamily="34" charset="-122"/>
                 <a:cs typeface="Arial" pitchFamily="34" charset="-120"/>
               </a:rPr>
-              <a:t>Cognition Runtime</a:t>
-            </a:r>
-            <a:endParaRPr lang="en-US" sz="5400" dirty="0"/>
+              <a:t>The mentor asks her name again.</a:t>
+            </a:r>
+            <a:endParaRPr lang="en-US" sz="4000" dirty="0"/>
           </a:p>
         </p:txBody>
       </p:sp>
@@ -2220,24 +2309,63 @@
         </p:nvSpPr>
         <p:spPr>
           <a:xfrm>
-            <a:off x="640080" y="3520440"/>
-            <a:ext cx="6949440" cy="731520"/>
-          </a:xfrm>
-          <a:prstGeom prst="rect">
-            <a:avLst/>
-          </a:prstGeom>
-          <a:noFill/>
-          <a:ln/>
-        </p:spPr>
-        <p:txBody>
-          <a:bodyPr wrap="square" lIns="0" tIns="0" rIns="0" bIns="0" rtlCol="0" anchor="ctr"/>
-          <a:lstStyle/>
-          <a:p>
-            <a:pPr indent="0" marL="0">
-              <a:buNone/>
-            </a:pPr>
-            <a:r>
-              <a:rPr lang="en-US" sz="1800" b="1" dirty="0">
+            <a:off x="640080" y="2852928"/>
+            <a:ext cx="6949440" cy="640080"/>
+          </a:xfrm>
+          <a:prstGeom prst="rect">
+            <a:avLst/>
+          </a:prstGeom>
+          <a:noFill/>
+          <a:ln/>
+        </p:spPr>
+        <p:txBody>
+          <a:bodyPr wrap="square" lIns="0" tIns="0" rIns="0" bIns="0" rtlCol="0" anchor="ctr"/>
+          <a:lstStyle/>
+          <a:p>
+            <a:pPr indent="0" marL="0">
+              <a:buNone/>
+            </a:pPr>
+            <a:r>
+              <a:rPr lang="en-US" sz="1450" dirty="0">
+                <a:solidFill>
+                  <a:srgbClr val="C6D4DA"/>
+                </a:solidFill>
+                <a:latin typeface="Arial" pitchFamily="34" charset="0"/>
+                <a:ea typeface="Arial" pitchFamily="34" charset="-122"/>
+                <a:cs typeface="Arial" pitchFamily="34" charset="-120"/>
+              </a:rPr>
+              <a:t>She trained with it all Monday. At midnight the session died — and with it every memory of her. That is every AI agent in 2026.</a:t>
+            </a:r>
+            <a:endParaRPr lang="en-US" sz="1450" dirty="0"/>
+          </a:p>
+        </p:txBody>
+      </p:sp>
+      <p:sp>
+        <p:nvSpPr>
+          <p:cNvPr id="30" name="Text 28"/>
+          <p:cNvSpPr/>
+          <p:nvPr/>
+        </p:nvSpPr>
+        <p:spPr>
+          <a:xfrm>
+            <a:off x="640080" y="3611880"/>
+            <a:ext cx="7223760" cy="685800"/>
+          </a:xfrm>
+          <a:prstGeom prst="rect">
+            <a:avLst/>
+          </a:prstGeom>
+          <a:noFill/>
+          <a:ln/>
+        </p:spPr>
+        <p:txBody>
+          <a:bodyPr wrap="square" lIns="0" tIns="0" rIns="0" bIns="0" rtlCol="0" anchor="ctr"/>
+          <a:lstStyle/>
+          <a:p>
+            <a:pPr indent="0" marL="0">
+              <a:buNone/>
+            </a:pPr>
+            <a:r>
+              <a:rPr lang="en-US" sz="1600" b="1" dirty="0">
                 <a:solidFill>
                   <a:srgbClr val="7FC4C9"/>
                 </a:solidFill>
@@ -2251,7 +2379,7 @@
               <a:buNone/>
             </a:pPr>
             <a:r>
-              <a:rPr lang="en-US" sz="1800" dirty="0">
+              <a:rPr lang="en-US" sz="1600" dirty="0">
                 <a:solidFill>
                   <a:srgbClr val="C6D4DA"/>
                 </a:solidFill>
@@ -2261,46 +2389,7 @@
               </a:rPr>
               <a:t>for students and small teams: AI mentors that remember them and prove what they did.</a:t>
             </a:r>
-            <a:endParaRPr lang="en-US" sz="1800" dirty="0"/>
-          </a:p>
-        </p:txBody>
-      </p:sp>
-      <p:sp>
-        <p:nvSpPr>
-          <p:cNvPr id="30" name="Text 28"/>
-          <p:cNvSpPr/>
-          <p:nvPr/>
-        </p:nvSpPr>
-        <p:spPr>
-          <a:xfrm>
-            <a:off x="640080" y="4343400"/>
-            <a:ext cx="7223760" cy="365760"/>
-          </a:xfrm>
-          <a:prstGeom prst="rect">
-            <a:avLst/>
-          </a:prstGeom>
-          <a:noFill/>
-          <a:ln/>
-        </p:spPr>
-        <p:txBody>
-          <a:bodyPr wrap="square" lIns="0" tIns="0" rIns="0" bIns="0" rtlCol="0" anchor="ctr"/>
-          <a:lstStyle/>
-          <a:p>
-            <a:pPr indent="0" marL="0">
-              <a:buNone/>
-            </a:pPr>
-            <a:r>
-              <a:rPr lang="en-US" sz="1350" dirty="0">
-                <a:solidFill>
-                  <a:srgbClr val="8FA6B0"/>
-                </a:solidFill>
-                <a:latin typeface="Arial" pitchFamily="34" charset="0"/>
-                <a:ea typeface="Arial" pitchFamily="34" charset="-122"/>
-                <a:cs typeface="Arial" pitchFamily="34" charset="-120"/>
-              </a:rPr>
-              <a:t>44 containers running right now  ·  467K memory vectors  ·  Society Protocol with receipts</a:t>
-            </a:r>
-            <a:endParaRPr lang="en-US" sz="1350" dirty="0"/>
+            <a:endParaRPr lang="en-US" sz="1600" dirty="0"/>
           </a:p>
         </p:txBody>
       </p:sp>
@@ -2312,13 +2401,15 @@
         </p:nvSpPr>
         <p:spPr>
           <a:xfrm>
-            <a:off x="640080" y="5623560"/>
-            <a:ext cx="6949440" cy="0"/>
-          </a:xfrm>
-          <a:prstGeom prst="line">
-            <a:avLst/>
-          </a:prstGeom>
-          <a:noFill/>
+            <a:off x="640080" y="4434840"/>
+            <a:ext cx="7040880" cy="896112"/>
+          </a:xfrm>
+          <a:prstGeom prst="rect">
+            <a:avLst/>
+          </a:prstGeom>
+          <a:solidFill>
+            <a:srgbClr val="17242C"/>
+          </a:solidFill>
           <a:ln w="12700">
             <a:solidFill>
               <a:srgbClr val="27414E"/>
@@ -2335,7 +2426,84 @@
         </p:nvSpPr>
         <p:spPr>
           <a:xfrm>
-            <a:off x="640080" y="5806440"/>
+            <a:off x="868680" y="4526280"/>
+            <a:ext cx="6629400" cy="731520"/>
+          </a:xfrm>
+          <a:prstGeom prst="rect">
+            <a:avLst/>
+          </a:prstGeom>
+          <a:noFill/>
+          <a:ln/>
+        </p:spPr>
+        <p:txBody>
+          <a:bodyPr wrap="square" lIns="0" tIns="0" rIns="0" bIns="0" rtlCol="0" anchor="ctr"/>
+          <a:lstStyle/>
+          <a:p>
+            <a:pPr indent="0" marL="0">
+              <a:buNone/>
+            </a:pPr>
+            <a:r>
+              <a:rPr lang="en-US" sz="1150" b="1" dirty="0">
+                <a:solidFill>
+                  <a:srgbClr val="7FC4C9"/>
+                </a:solidFill>
+                <a:latin typeface="Courier New" pitchFamily="34" charset="0"/>
+                <a:ea typeface="Courier New" pitchFamily="34" charset="-122"/>
+                <a:cs typeface="Courier New" pitchFamily="34" charset="-120"/>
+              </a:rPr>
+              <a:t>receipt · 2026-10-22 · job 3bff070c-794d-42da-86ce-ce7296399390
+</a:t>
+            </a:r>
+            <a:pPr indent="0" marL="0">
+              <a:buNone/>
+            </a:pPr>
+            <a:r>
+              <a:rPr lang="en-US" sz="1150" dirty="0">
+                <a:solidFill>
+                  <a:srgbClr val="8FA6B0"/>
+                </a:solidFill>
+                <a:latin typeface="Arial" pitchFamily="34" charset="0"/>
+                <a:ea typeface="Arial" pitchFamily="34" charset="-122"/>
+                <a:cs typeface="Arial" pitchFamily="34" charset="-120"/>
+              </a:rPr>
+              <a:t>live assistant turn completed, LLM-judge verdict recorded — every claim in this deck is checkable</a:t>
+            </a:r>
+            <a:endParaRPr lang="en-US" sz="1150" dirty="0"/>
+          </a:p>
+        </p:txBody>
+      </p:sp>
+      <p:sp>
+        <p:nvSpPr>
+          <p:cNvPr id="33" name="Shape 31"/>
+          <p:cNvSpPr/>
+          <p:nvPr/>
+        </p:nvSpPr>
+        <p:spPr>
+          <a:xfrm>
+            <a:off x="640080" y="5943600"/>
+            <a:ext cx="6949440" cy="0"/>
+          </a:xfrm>
+          <a:prstGeom prst="line">
+            <a:avLst/>
+          </a:prstGeom>
+          <a:noFill/>
+          <a:ln w="12700">
+            <a:solidFill>
+              <a:srgbClr val="27414E"/>
+            </a:solidFill>
+            <a:prstDash val="solid"/>
+          </a:ln>
+        </p:spPr>
+      </p:sp>
+      <p:sp>
+        <p:nvSpPr>
+          <p:cNvPr id="34" name="Text 32"/>
+          <p:cNvSpPr/>
+          <p:nvPr/>
+        </p:nvSpPr>
+        <p:spPr>
+          <a:xfrm>
+            <a:off x="640080" y="6108192"/>
             <a:ext cx="8686800" cy="320040"/>
           </a:xfrm>
           <a:prstGeom prst="rect">
@@ -2352,7 +2520,7 @@
               <a:buNone/>
             </a:pPr>
             <a:r>
-              <a:rPr lang="en-US" sz="1300" dirty="0">
+              <a:rPr lang="en-US" sz="1250" dirty="0">
                 <a:solidFill>
                   <a:srgbClr val="C6D4DA"/>
                 </a:solidFill>
@@ -2362,19 +2530,19 @@
               </a:rPr>
               <a:t>Valentin Kalinin, founder   ·   valentin@mind.glass   ·   github.com/tdesc/colony-ai-deck   ·   Saint Petersburg</a:t>
             </a:r>
-            <a:endParaRPr lang="en-US" sz="1300" dirty="0"/>
-          </a:p>
-        </p:txBody>
-      </p:sp>
-      <p:sp>
-        <p:nvSpPr>
-          <p:cNvPr id="33" name="Shape 31"/>
-          <p:cNvSpPr/>
-          <p:nvPr/>
-        </p:nvSpPr>
-        <p:spPr>
-          <a:xfrm>
-            <a:off x="640080" y="4892040"/>
+            <a:endParaRPr lang="en-US" sz="1250" dirty="0"/>
+          </a:p>
+        </p:txBody>
+      </p:sp>
+      <p:sp>
+        <p:nvSpPr>
+          <p:cNvPr id="35" name="Shape 33"/>
+          <p:cNvSpPr/>
+          <p:nvPr/>
+        </p:nvSpPr>
+        <p:spPr>
+          <a:xfrm>
+            <a:off x="640080" y="5532120"/>
             <a:ext cx="3931920" cy="329184"/>
           </a:xfrm>
           <a:prstGeom prst="roundRect">
@@ -2395,13 +2563,13 @@
       </p:sp>
       <p:sp>
         <p:nvSpPr>
-          <p:cNvPr id="34" name="Text 32"/>
-          <p:cNvSpPr/>
-          <p:nvPr/>
-        </p:nvSpPr>
-        <p:spPr>
-          <a:xfrm>
-            <a:off x="640080" y="4892040"/>
+          <p:cNvPr id="36" name="Text 34"/>
+          <p:cNvSpPr/>
+          <p:nvPr/>
+        </p:nvSpPr>
+        <p:spPr>
+          <a:xfrm>
+            <a:off x="640080" y="5532120"/>
             <a:ext cx="3931920" cy="329184"/>
           </a:xfrm>
           <a:prstGeom prst="rect">
@@ -2429,6 +2597,681 @@
               <a:t>RECEIPT · LIVE FLEET · 2026-10-21</a:t>
             </a:r>
             <a:endParaRPr lang="en-US" sz="1200" dirty="0"/>
+          </a:p>
+        </p:txBody>
+      </p:sp>
+    </p:spTree>
+  </p:cSld>
+  <p:clrMapOvr>
+    <a:masterClrMapping/>
+  </p:clrMapOvr>
+</p:sld>
+</file>
+
+<file path=ppt/slides/slide10.xml><?xml version="1.0" encoding="utf-8"?>
+<p:sld xmlns:a="http://schemas.openxmlformats.org/drawingml/2006/main" xmlns:r="http://schemas.openxmlformats.org/officeDocument/2006/relationships" xmlns:p="http://schemas.openxmlformats.org/presentationml/2006/main">
+  <p:cSld name="Slide 10">
+    <p:bg>
+      <p:bgPr>
+        <a:solidFill>
+          <a:srgbClr val="0D1B24"/>
+        </a:solidFill>
+      </p:bgPr>
+    </p:bg>
+    <p:spTree>
+      <p:nvGrpSpPr>
+        <p:cNvPr id="1" name=""/>
+        <p:cNvGrpSpPr/>
+        <p:nvPr/>
+      </p:nvGrpSpPr>
+      <p:grpSpPr>
+        <a:xfrm>
+          <a:off x="0" y="0"/>
+          <a:ext cx="0" cy="0"/>
+          <a:chOff x="0" y="0"/>
+          <a:chExt cx="0" cy="0"/>
+        </a:xfrm>
+      </p:grpSpPr>
+      <p:sp>
+        <p:nvSpPr>
+          <p:cNvPr id="2" name="Shape 0"/>
+          <p:cNvSpPr/>
+          <p:nvPr/>
+        </p:nvSpPr>
+        <p:spPr>
+          <a:xfrm>
+            <a:off x="10332720" y="5120640"/>
+            <a:ext cx="1083323" cy="503049"/>
+          </a:xfrm>
+          <a:prstGeom prst="line">
+            <a:avLst/>
+          </a:prstGeom>
+          <a:noFill/>
+          <a:ln w="12700">
+            <a:solidFill>
+              <a:srgbClr val="27414E"/>
+            </a:solidFill>
+            <a:prstDash val="solid"/>
+          </a:ln>
+        </p:spPr>
+      </p:sp>
+      <p:sp>
+        <p:nvSpPr>
+          <p:cNvPr id="3" name="Shape 1"/>
+          <p:cNvSpPr/>
+          <p:nvPr/>
+        </p:nvSpPr>
+        <p:spPr>
+          <a:xfrm>
+            <a:off x="10332720" y="5120640"/>
+            <a:ext cx="29129" cy="1048982"/>
+          </a:xfrm>
+          <a:prstGeom prst="line">
+            <a:avLst/>
+          </a:prstGeom>
+          <a:noFill/>
+          <a:ln w="12700">
+            <a:solidFill>
+              <a:srgbClr val="27414E"/>
+            </a:solidFill>
+            <a:prstDash val="solid"/>
+          </a:ln>
+        </p:spPr>
+      </p:sp>
+      <p:sp>
+        <p:nvSpPr>
+          <p:cNvPr id="4" name="Shape 2"/>
+          <p:cNvSpPr/>
+          <p:nvPr/>
+        </p:nvSpPr>
+        <p:spPr>
+          <a:xfrm>
+            <a:off x="10332720" y="5120640"/>
+            <a:ext cx="-1054194" cy="545933"/>
+          </a:xfrm>
+          <a:prstGeom prst="line">
+            <a:avLst/>
+          </a:prstGeom>
+          <a:noFill/>
+          <a:ln w="12700">
+            <a:solidFill>
+              <a:srgbClr val="27414E"/>
+            </a:solidFill>
+            <a:prstDash val="solid"/>
+          </a:ln>
+        </p:spPr>
+      </p:sp>
+      <p:sp>
+        <p:nvSpPr>
+          <p:cNvPr id="5" name="Shape 3"/>
+          <p:cNvSpPr/>
+          <p:nvPr/>
+        </p:nvSpPr>
+        <p:spPr>
+          <a:xfrm>
+            <a:off x="10332720" y="5120640"/>
+            <a:ext cx="-1083323" cy="-503049"/>
+          </a:xfrm>
+          <a:prstGeom prst="line">
+            <a:avLst/>
+          </a:prstGeom>
+          <a:noFill/>
+          <a:ln w="12700">
+            <a:solidFill>
+              <a:srgbClr val="27414E"/>
+            </a:solidFill>
+            <a:prstDash val="solid"/>
+          </a:ln>
+        </p:spPr>
+      </p:sp>
+      <p:sp>
+        <p:nvSpPr>
+          <p:cNvPr id="6" name="Shape 4"/>
+          <p:cNvSpPr/>
+          <p:nvPr/>
+        </p:nvSpPr>
+        <p:spPr>
+          <a:xfrm>
+            <a:off x="10332720" y="5120640"/>
+            <a:ext cx="-29129" cy="-1048982"/>
+          </a:xfrm>
+          <a:prstGeom prst="line">
+            <a:avLst/>
+          </a:prstGeom>
+          <a:noFill/>
+          <a:ln w="12700">
+            <a:solidFill>
+              <a:srgbClr val="27414E"/>
+            </a:solidFill>
+            <a:prstDash val="solid"/>
+          </a:ln>
+        </p:spPr>
+      </p:sp>
+      <p:sp>
+        <p:nvSpPr>
+          <p:cNvPr id="7" name="Shape 5"/>
+          <p:cNvSpPr/>
+          <p:nvPr/>
+        </p:nvSpPr>
+        <p:spPr>
+          <a:xfrm>
+            <a:off x="10332720" y="5120640"/>
+            <a:ext cx="1054194" cy="-545933"/>
+          </a:xfrm>
+          <a:prstGeom prst="line">
+            <a:avLst/>
+          </a:prstGeom>
+          <a:noFill/>
+          <a:ln w="12700">
+            <a:solidFill>
+              <a:srgbClr val="27414E"/>
+            </a:solidFill>
+            <a:prstDash val="solid"/>
+          </a:ln>
+        </p:spPr>
+      </p:sp>
+      <p:sp>
+        <p:nvSpPr>
+          <p:cNvPr id="8" name="Shape 6"/>
+          <p:cNvSpPr/>
+          <p:nvPr/>
+        </p:nvSpPr>
+        <p:spPr>
+          <a:xfrm>
+            <a:off x="11347463" y="5555109"/>
+            <a:ext cx="137160" cy="137160"/>
+          </a:xfrm>
+          <a:prstGeom prst="ellipse">
+            <a:avLst/>
+          </a:prstGeom>
+          <a:solidFill>
+            <a:srgbClr val="7FC4C9"/>
+          </a:solidFill>
+          <a:ln/>
+        </p:spPr>
+      </p:sp>
+      <p:sp>
+        <p:nvSpPr>
+          <p:cNvPr id="9" name="Shape 7"/>
+          <p:cNvSpPr/>
+          <p:nvPr/>
+        </p:nvSpPr>
+        <p:spPr>
+          <a:xfrm>
+            <a:off x="10311557" y="6119330"/>
+            <a:ext cx="100584" cy="100584"/>
+          </a:xfrm>
+          <a:prstGeom prst="ellipse">
+            <a:avLst/>
+          </a:prstGeom>
+          <a:solidFill>
+            <a:srgbClr val="7FC4C9"/>
+          </a:solidFill>
+          <a:ln/>
+        </p:spPr>
+      </p:sp>
+      <p:sp>
+        <p:nvSpPr>
+          <p:cNvPr id="10" name="Shape 8"/>
+          <p:cNvSpPr/>
+          <p:nvPr/>
+        </p:nvSpPr>
+        <p:spPr>
+          <a:xfrm>
+            <a:off x="9209946" y="5597993"/>
+            <a:ext cx="137160" cy="137160"/>
+          </a:xfrm>
+          <a:prstGeom prst="ellipse">
+            <a:avLst/>
+          </a:prstGeom>
+          <a:solidFill>
+            <a:srgbClr val="D97706"/>
+          </a:solidFill>
+          <a:ln/>
+        </p:spPr>
+      </p:sp>
+      <p:sp>
+        <p:nvSpPr>
+          <p:cNvPr id="11" name="Shape 9"/>
+          <p:cNvSpPr/>
+          <p:nvPr/>
+        </p:nvSpPr>
+        <p:spPr>
+          <a:xfrm>
+            <a:off x="9199105" y="4567299"/>
+            <a:ext cx="100584" cy="100584"/>
+          </a:xfrm>
+          <a:prstGeom prst="ellipse">
+            <a:avLst/>
+          </a:prstGeom>
+          <a:solidFill>
+            <a:srgbClr val="7FC4C9"/>
+          </a:solidFill>
+          <a:ln/>
+        </p:spPr>
+      </p:sp>
+      <p:sp>
+        <p:nvSpPr>
+          <p:cNvPr id="12" name="Shape 10"/>
+          <p:cNvSpPr/>
+          <p:nvPr/>
+        </p:nvSpPr>
+        <p:spPr>
+          <a:xfrm>
+            <a:off x="10235011" y="4003078"/>
+            <a:ext cx="137160" cy="137160"/>
+          </a:xfrm>
+          <a:prstGeom prst="ellipse">
+            <a:avLst/>
+          </a:prstGeom>
+          <a:solidFill>
+            <a:srgbClr val="7FC4C9"/>
+          </a:solidFill>
+          <a:ln/>
+        </p:spPr>
+      </p:sp>
+      <p:sp>
+        <p:nvSpPr>
+          <p:cNvPr id="13" name="Shape 11"/>
+          <p:cNvSpPr/>
+          <p:nvPr/>
+        </p:nvSpPr>
+        <p:spPr>
+          <a:xfrm>
+            <a:off x="11336622" y="4524415"/>
+            <a:ext cx="100584" cy="100584"/>
+          </a:xfrm>
+          <a:prstGeom prst="ellipse">
+            <a:avLst/>
+          </a:prstGeom>
+          <a:solidFill>
+            <a:srgbClr val="7FC4C9"/>
+          </a:solidFill>
+          <a:ln/>
+        </p:spPr>
+      </p:sp>
+      <p:sp>
+        <p:nvSpPr>
+          <p:cNvPr id="14" name="Shape 12"/>
+          <p:cNvSpPr/>
+          <p:nvPr/>
+        </p:nvSpPr>
+        <p:spPr>
+          <a:xfrm>
+            <a:off x="10222992" y="5010912"/>
+            <a:ext cx="219456" cy="219456"/>
+          </a:xfrm>
+          <a:prstGeom prst="ellipse">
+            <a:avLst/>
+          </a:prstGeom>
+          <a:solidFill>
+            <a:srgbClr val="D97706"/>
+          </a:solidFill>
+          <a:ln/>
+        </p:spPr>
+      </p:sp>
+      <p:sp>
+        <p:nvSpPr>
+          <p:cNvPr id="15" name="Text 13"/>
+          <p:cNvSpPr/>
+          <p:nvPr/>
+        </p:nvSpPr>
+        <p:spPr>
+          <a:xfrm>
+            <a:off x="640080" y="822960"/>
+            <a:ext cx="6400800" cy="320040"/>
+          </a:xfrm>
+          <a:prstGeom prst="rect">
+            <a:avLst/>
+          </a:prstGeom>
+          <a:noFill/>
+          <a:ln/>
+        </p:spPr>
+        <p:txBody>
+          <a:bodyPr wrap="square" lIns="0" tIns="0" rIns="0" bIns="0" rtlCol="0" anchor="ctr"/>
+          <a:lstStyle/>
+          <a:p>
+            <a:pPr indent="0" marL="0">
+              <a:buNone/>
+            </a:pPr>
+            <a:r>
+              <a:rPr lang="en-US" sz="1300" b="1" spc="400" kern="0" dirty="0">
+                <a:solidFill>
+                  <a:srgbClr val="D97706"/>
+                </a:solidFill>
+                <a:latin typeface="Arial" pitchFamily="34" charset="0"/>
+                <a:ea typeface="Arial" pitchFamily="34" charset="-122"/>
+                <a:cs typeface="Arial" pitchFamily="34" charset="-120"/>
+              </a:rPr>
+              <a:t>TEAM &amp; CONTACT</a:t>
+            </a:r>
+            <a:endParaRPr lang="en-US" sz="1300" dirty="0"/>
+          </a:p>
+        </p:txBody>
+      </p:sp>
+      <p:sp>
+        <p:nvSpPr>
+          <p:cNvPr id="16" name="Text 14"/>
+          <p:cNvSpPr/>
+          <p:nvPr/>
+        </p:nvSpPr>
+        <p:spPr>
+          <a:xfrm>
+            <a:off x="640080" y="1371600"/>
+            <a:ext cx="8229600" cy="868680"/>
+          </a:xfrm>
+          <a:prstGeom prst="rect">
+            <a:avLst/>
+          </a:prstGeom>
+          <a:noFill/>
+          <a:ln/>
+        </p:spPr>
+        <p:txBody>
+          <a:bodyPr wrap="square" lIns="0" tIns="0" rIns="0" bIns="0" rtlCol="0" anchor="ctr"/>
+          <a:lstStyle/>
+          <a:p>
+            <a:pPr indent="0" marL="0">
+              <a:buNone/>
+            </a:pPr>
+            <a:r>
+              <a:rPr lang="en-US" sz="4400" b="1" dirty="0">
+                <a:solidFill>
+                  <a:srgbClr val="FFFFFF"/>
+                </a:solidFill>
+                <a:latin typeface="Arial" pitchFamily="34" charset="0"/>
+                <a:ea typeface="Arial" pitchFamily="34" charset="-122"/>
+                <a:cs typeface="Arial" pitchFamily="34" charset="-120"/>
+              </a:rPr>
+              <a:t>Valentin Kalinin</a:t>
+            </a:r>
+            <a:endParaRPr lang="en-US" sz="4400" dirty="0"/>
+          </a:p>
+        </p:txBody>
+      </p:sp>
+      <p:sp>
+        <p:nvSpPr>
+          <p:cNvPr id="17" name="Text 15"/>
+          <p:cNvSpPr/>
+          <p:nvPr/>
+        </p:nvSpPr>
+        <p:spPr>
+          <a:xfrm>
+            <a:off x="640080" y="2331720"/>
+            <a:ext cx="7863840" cy="685800"/>
+          </a:xfrm>
+          <a:prstGeom prst="rect">
+            <a:avLst/>
+          </a:prstGeom>
+          <a:noFill/>
+          <a:ln/>
+        </p:spPr>
+        <p:txBody>
+          <a:bodyPr wrap="square" lIns="0" tIns="0" rIns="0" bIns="0" rtlCol="0" anchor="ctr"/>
+          <a:lstStyle/>
+          <a:p>
+            <a:pPr indent="0" marL="0">
+              <a:lnSpc>
+                <a:spcPts val="2200"/>
+              </a:lnSpc>
+              <a:buNone/>
+            </a:pPr>
+            <a:r>
+              <a:rPr lang="en-US" sz="1600" dirty="0">
+                <a:solidFill>
+                  <a:srgbClr val="C6D4DA"/>
+                </a:solidFill>
+                <a:latin typeface="Arial" pitchFamily="34" charset="0"/>
+                <a:ea typeface="Arial" pitchFamily="34" charset="-122"/>
+                <a:cs typeface="Arial" pitchFamily="34" charset="-120"/>
+              </a:rPr>
+              <a:t>Founder — built the whole stack solo: cognition runtime, Society Protocol, mentor fleet, Dota 2 Copilot.</a:t>
+            </a:r>
+            <a:endParaRPr lang="en-US" sz="1600" dirty="0"/>
+          </a:p>
+        </p:txBody>
+      </p:sp>
+      <p:sp>
+        <p:nvSpPr>
+          <p:cNvPr id="18" name="Shape 16"/>
+          <p:cNvSpPr/>
+          <p:nvPr/>
+        </p:nvSpPr>
+        <p:spPr>
+          <a:xfrm>
+            <a:off x="640080" y="3429000"/>
+            <a:ext cx="7863840" cy="0"/>
+          </a:xfrm>
+          <a:prstGeom prst="line">
+            <a:avLst/>
+          </a:prstGeom>
+          <a:noFill/>
+          <a:ln w="12700">
+            <a:solidFill>
+              <a:srgbClr val="27414E"/>
+            </a:solidFill>
+            <a:prstDash val="solid"/>
+          </a:ln>
+        </p:spPr>
+      </p:sp>
+      <p:sp>
+        <p:nvSpPr>
+          <p:cNvPr id="19" name="Text 17"/>
+          <p:cNvSpPr/>
+          <p:nvPr/>
+        </p:nvSpPr>
+        <p:spPr>
+          <a:xfrm>
+            <a:off x="640080" y="3657600"/>
+            <a:ext cx="7863840" cy="457200"/>
+          </a:xfrm>
+          <a:prstGeom prst="rect">
+            <a:avLst/>
+          </a:prstGeom>
+          <a:noFill/>
+          <a:ln/>
+        </p:spPr>
+        <p:txBody>
+          <a:bodyPr wrap="square" lIns="0" tIns="0" rIns="0" bIns="0" rtlCol="0" anchor="ctr"/>
+          <a:lstStyle/>
+          <a:p>
+            <a:pPr indent="0" marL="0">
+              <a:buNone/>
+            </a:pPr>
+            <a:r>
+              <a:rPr lang="en-US" sz="2400" b="1" dirty="0">
+                <a:solidFill>
+                  <a:srgbClr val="D97706"/>
+                </a:solidFill>
+                <a:latin typeface="Arial" pitchFamily="34" charset="0"/>
+                <a:ea typeface="Arial" pitchFamily="34" charset="-122"/>
+                <a:cs typeface="Arial" pitchFamily="34" charset="-120"/>
+              </a:rPr>
+              <a:t>valentin@mind.glass</a:t>
+            </a:r>
+            <a:endParaRPr lang="en-US" sz="2400" dirty="0"/>
+          </a:p>
+        </p:txBody>
+      </p:sp>
+      <p:sp>
+        <p:nvSpPr>
+          <p:cNvPr id="20" name="Text 18"/>
+          <p:cNvSpPr/>
+          <p:nvPr/>
+        </p:nvSpPr>
+        <p:spPr>
+          <a:xfrm>
+            <a:off x="640080" y="4224528"/>
+            <a:ext cx="7863840" cy="457200"/>
+          </a:xfrm>
+          <a:prstGeom prst="rect">
+            <a:avLst/>
+          </a:prstGeom>
+          <a:noFill/>
+          <a:ln/>
+        </p:spPr>
+        <p:txBody>
+          <a:bodyPr wrap="square" lIns="0" tIns="0" rIns="0" bIns="0" rtlCol="0" anchor="ctr"/>
+          <a:lstStyle/>
+          <a:p>
+            <a:pPr indent="0" marL="0">
+              <a:buNone/>
+            </a:pPr>
+            <a:r>
+              <a:rPr lang="en-US" sz="1800" dirty="0">
+                <a:solidFill>
+                  <a:srgbClr val="C6D4DA"/>
+                </a:solidFill>
+                <a:latin typeface="Arial" pitchFamily="34" charset="0"/>
+                <a:ea typeface="Arial" pitchFamily="34" charset="-122"/>
+                <a:cs typeface="Arial" pitchFamily="34" charset="-120"/>
+              </a:rPr>
+              <a:t>github.com/tdesc/colony-ai-deck</a:t>
+            </a:r>
+            <a:endParaRPr lang="en-US" sz="1800" dirty="0"/>
+          </a:p>
+        </p:txBody>
+      </p:sp>
+      <p:sp>
+        <p:nvSpPr>
+          <p:cNvPr id="21" name="Text 19"/>
+          <p:cNvSpPr/>
+          <p:nvPr/>
+        </p:nvSpPr>
+        <p:spPr>
+          <a:xfrm>
+            <a:off x="640080" y="4791456"/>
+            <a:ext cx="7863840" cy="457200"/>
+          </a:xfrm>
+          <a:prstGeom prst="rect">
+            <a:avLst/>
+          </a:prstGeom>
+          <a:noFill/>
+          <a:ln/>
+        </p:spPr>
+        <p:txBody>
+          <a:bodyPr wrap="square" lIns="0" tIns="0" rIns="0" bIns="0" rtlCol="0" anchor="ctr"/>
+          <a:lstStyle/>
+          <a:p>
+            <a:pPr indent="0" marL="0">
+              <a:buNone/>
+            </a:pPr>
+            <a:r>
+              <a:rPr lang="en-US" sz="1800" dirty="0">
+                <a:solidFill>
+                  <a:srgbClr val="C6D4DA"/>
+                </a:solidFill>
+                <a:latin typeface="Arial" pitchFamily="34" charset="0"/>
+                <a:ea typeface="Arial" pitchFamily="34" charset="-122"/>
+                <a:cs typeface="Arial" pitchFamily="34" charset="-120"/>
+              </a:rPr>
+              <a:t>mind.glass  ·  Saint Petersburg, Russia</a:t>
+            </a:r>
+            <a:endParaRPr lang="en-US" sz="1800" dirty="0"/>
+          </a:p>
+        </p:txBody>
+      </p:sp>
+      <p:sp>
+        <p:nvSpPr>
+          <p:cNvPr id="22" name="Shape 20"/>
+          <p:cNvSpPr/>
+          <p:nvPr/>
+        </p:nvSpPr>
+        <p:spPr>
+          <a:xfrm>
+            <a:off x="640080" y="5806440"/>
+            <a:ext cx="5852160" cy="329184"/>
+          </a:xfrm>
+          <a:prstGeom prst="roundRect">
+            <a:avLst>
+              <a:gd name="adj" fmla="val 50000"/>
+            </a:avLst>
+          </a:prstGeom>
+          <a:solidFill>
+            <a:srgbClr val="0D1B24"/>
+          </a:solidFill>
+          <a:ln w="12700">
+            <a:solidFill>
+              <a:srgbClr val="D97706"/>
+            </a:solidFill>
+            <a:prstDash val="solid"/>
+          </a:ln>
+        </p:spPr>
+      </p:sp>
+      <p:sp>
+        <p:nvSpPr>
+          <p:cNvPr id="23" name="Text 21"/>
+          <p:cNvSpPr/>
+          <p:nvPr/>
+        </p:nvSpPr>
+        <p:spPr>
+          <a:xfrm>
+            <a:off x="640080" y="5806440"/>
+            <a:ext cx="5852160" cy="329184"/>
+          </a:xfrm>
+          <a:prstGeom prst="rect">
+            <a:avLst/>
+          </a:prstGeom>
+          <a:noFill/>
+          <a:ln/>
+        </p:spPr>
+        <p:txBody>
+          <a:bodyPr wrap="square" lIns="0" tIns="0" rIns="0" bIns="0" rtlCol="0" anchor="ctr"/>
+          <a:lstStyle/>
+          <a:p>
+            <a:pPr algn="ctr" indent="0" marL="0">
+              <a:buNone/>
+            </a:pPr>
+            <a:r>
+              <a:rPr lang="en-US" sz="1200" b="1" spc="100" kern="0" dirty="0">
+                <a:solidFill>
+                  <a:srgbClr val="D97706"/>
+                </a:solidFill>
+                <a:latin typeface="Arial" pitchFamily="34" charset="0"/>
+                <a:ea typeface="Arial" pitchFamily="34" charset="-122"/>
+                <a:cs typeface="Arial" pitchFamily="34" charset="-120"/>
+              </a:rPr>
+              <a:t>RECEIPT · SELF-FUNDED WORKING PROTOTYPE · OCT 2026</a:t>
+            </a:r>
+            <a:endParaRPr lang="en-US" sz="1200" dirty="0"/>
+          </a:p>
+        </p:txBody>
+      </p:sp>
+      <p:sp>
+        <p:nvSpPr>
+          <p:cNvPr id="24" name="Text 22"/>
+          <p:cNvSpPr/>
+          <p:nvPr/>
+        </p:nvSpPr>
+        <p:spPr>
+          <a:xfrm>
+            <a:off x="640080" y="6355080"/>
+            <a:ext cx="7315200" cy="320040"/>
+          </a:xfrm>
+          <a:prstGeom prst="rect">
+            <a:avLst/>
+          </a:prstGeom>
+          <a:noFill/>
+          <a:ln/>
+        </p:spPr>
+        <p:txBody>
+          <a:bodyPr wrap="square" lIns="0" tIns="0" rIns="0" bIns="0" rtlCol="0" anchor="ctr"/>
+          <a:lstStyle/>
+          <a:p>
+            <a:pPr indent="0" marL="0">
+              <a:buNone/>
+            </a:pPr>
+            <a:r>
+              <a:rPr lang="en-US" sz="1300" dirty="0">
+                <a:solidFill>
+                  <a:srgbClr val="8FA6B0"/>
+                </a:solidFill>
+                <a:latin typeface="Arial" pitchFamily="34" charset="0"/>
+                <a:ea typeface="Arial" pitchFamily="34" charset="-122"/>
+                <a:cs typeface="Arial" pitchFamily="34" charset="-120"/>
+              </a:rPr>
+              <a:t>Colony AI — Mentor as a Service</a:t>
+            </a:r>
+            <a:endParaRPr lang="en-US" sz="1300" dirty="0"/>
           </a:p>
         </p:txBody>
       </p:sp>
@@ -2536,7 +3379,7 @@
                 <a:ea typeface="Arial" pitchFamily="34" charset="-122"/>
                 <a:cs typeface="Arial" pitchFamily="34" charset="-120"/>
               </a:rPr>
-              <a:t>Tuesday. The mentor asks her name again.</a:t>
+              <a:t>LLM agents wake up with no past and no rules.</a:t>
             </a:r>
             <a:endParaRPr lang="en-US" sz="3000" dirty="0"/>
           </a:p>
@@ -2551,7 +3394,7 @@
         <p:spPr>
           <a:xfrm>
             <a:off x="548640" y="1389888"/>
-            <a:ext cx="10424160" cy="685800"/>
+            <a:ext cx="10424160" cy="365760"/>
           </a:xfrm>
           <a:prstGeom prst="rect">
             <a:avLst/>
@@ -2575,7 +3418,7 @@
                 <a:ea typeface="Arial" pitchFamily="34" charset="-122"/>
                 <a:cs typeface="Arial" pitchFamily="34" charset="-120"/>
               </a:rPr>
-              <a:t>She trained with it all Monday. At midnight the session died — and with it every memory of her. That is every AI agent in 2026.</a:t>
+              <a:t>Anyone can spawn a hundred agents in 2026. Almost nobody can govern them — or trust what they claim.</a:t>
             </a:r>
             <a:endParaRPr lang="en-US" sz="1500" dirty="0"/>
           </a:p>
@@ -4128,7 +4971,7 @@
                 <a:ea typeface="Arial" pitchFamily="34" charset="-122"/>
                 <a:cs typeface="Arial" pitchFamily="34" charset="-120"/>
               </a:rPr>
-              <a:t> Goal-setting, homework, follow-up. Voice-ready: 170 ms turn-taking on the local speech bench.</a:t>
+              <a:t> Goal-setting, homework, follow-up. Voice-ready: 170 ms turn-taking measured on a single-machine local speech bench.</a:t>
             </a:r>
             <a:endParaRPr lang="en-US" sz="1450" dirty="0"/>
           </a:p>
@@ -5159,7 +6002,7 @@
                 <a:ea typeface="Arial" pitchFamily="34" charset="-122"/>
                 <a:cs typeface="Arial" pitchFamily="34" charset="-120"/>
               </a:rPr>
-              <a:t>A paid lane from day one.</a:t>
+              <a:t>Designed as a paid lane.</a:t>
             </a:r>
             <a:pPr indent="0" marL="0">
               <a:lnSpc>
@@ -5176,7 +6019,7 @@
                 <a:ea typeface="Arial" pitchFamily="34" charset="-122"/>
                 <a:cs typeface="Arial" pitchFamily="34" charset="-120"/>
               </a:rPr>
-              <a:t> Premium tier served over a dedicated MCP server — subscription access to the copilot.</a:t>
+              <a:t> Premium tier over a dedicated MCP server — subscription architecture is live; billing is not yet switched on.</a:t>
             </a:r>
             <a:endParaRPr lang="en-US" sz="1450" dirty="0"/>
           </a:p>
@@ -5235,7 +6078,7 @@
                 <a:ea typeface="Arial" pitchFamily="34" charset="-122"/>
                 <a:cs typeface="Arial" pitchFamily="34" charset="-120"/>
               </a:rPr>
-              <a:t> Proof the runtime survives realtime, high-stakes load. If it holds here, it holds anywhere.</a:t>
+              <a:t> The hardest domain the runtime has survived so far — realtime load, per-player memory, traceable decisions.</a:t>
             </a:r>
             <a:endParaRPr lang="en-US" sz="1450" dirty="0"/>
           </a:p>
@@ -6485,7 +7328,7 @@
                 <a:ea typeface="Arial" pitchFamily="34" charset="-122"/>
                 <a:cs typeface="Arial" pitchFamily="34" charset="-120"/>
               </a:rPr>
-              <a:t>WHY CLOUD CREDITS</a:t>
+              <a:t>PROOF · ARTIFACTS</a:t>
             </a:r>
             <a:endParaRPr lang="en-US" sz="1200" dirty="0"/>
           </a:p>
@@ -6524,7 +7367,7 @@
                 <a:ea typeface="Arial" pitchFamily="34" charset="-122"/>
                 <a:cs typeface="Arial" pitchFamily="34" charset="-120"/>
               </a:rPr>
-              <a:t>Grow the fleet from one box to a cloud.</a:t>
+              <a:t>Receipts you can open.</a:t>
             </a:r>
             <a:endParaRPr lang="en-US" sz="3000" dirty="0"/>
           </a:p>
@@ -6538,7 +7381,7 @@
         </p:nvSpPr>
         <p:spPr>
           <a:xfrm>
-            <a:off x="548640" y="1581912"/>
+            <a:off x="548640" y="1673352"/>
             <a:ext cx="11091672" cy="0"/>
           </a:xfrm>
           <a:prstGeom prst="line">
@@ -6561,34 +7404,34 @@
         </p:nvSpPr>
         <p:spPr>
           <a:xfrm>
-            <a:off x="548640" y="1737360"/>
-            <a:ext cx="731520" cy="777240"/>
-          </a:xfrm>
-          <a:prstGeom prst="rect">
-            <a:avLst/>
-          </a:prstGeom>
-          <a:noFill/>
-          <a:ln/>
-        </p:spPr>
-        <p:txBody>
-          <a:bodyPr wrap="square" lIns="0" tIns="0" rIns="0" bIns="0" rtlCol="0" anchor="ctr"/>
-          <a:lstStyle/>
-          <a:p>
-            <a:pPr indent="0" marL="0">
-              <a:buNone/>
-            </a:pPr>
-            <a:r>
-              <a:rPr lang="en-US" sz="4000" b="1" dirty="0">
-                <a:solidFill>
-                  <a:srgbClr val="0B5D66"/>
-                </a:solidFill>
-                <a:latin typeface="Arial" pitchFamily="34" charset="0"/>
-                <a:ea typeface="Arial" pitchFamily="34" charset="-122"/>
-                <a:cs typeface="Arial" pitchFamily="34" charset="-120"/>
-              </a:rPr>
-              <a:t>1</a:t>
-            </a:r>
-            <a:endParaRPr lang="en-US" sz="4000" dirty="0"/>
+            <a:off x="548640" y="1783080"/>
+            <a:ext cx="3291840" cy="365760"/>
+          </a:xfrm>
+          <a:prstGeom prst="rect">
+            <a:avLst/>
+          </a:prstGeom>
+          <a:noFill/>
+          <a:ln/>
+        </p:spPr>
+        <p:txBody>
+          <a:bodyPr wrap="square" lIns="0" tIns="0" rIns="0" bIns="0" rtlCol="0" anchor="ctr"/>
+          <a:lstStyle/>
+          <a:p>
+            <a:pPr indent="0" marL="0">
+              <a:buNone/>
+            </a:pPr>
+            <a:r>
+              <a:rPr lang="en-US" sz="1450" b="1" dirty="0">
+                <a:solidFill>
+                  <a:srgbClr val="083F45"/>
+                </a:solidFill>
+                <a:latin typeface="Courier New" pitchFamily="34" charset="0"/>
+                <a:ea typeface="Courier New" pitchFamily="34" charset="-122"/>
+                <a:cs typeface="Courier New" pitchFamily="34" charset="-120"/>
+              </a:rPr>
+              <a:t>job 3bff070c…9390</a:t>
+            </a:r>
+            <a:endParaRPr lang="en-US" sz="1450" dirty="0"/>
           </a:p>
         </p:txBody>
       </p:sp>
@@ -6600,63 +7443,24 @@
         </p:nvSpPr>
         <p:spPr>
           <a:xfrm>
-            <a:off x="1554480" y="1709928"/>
-            <a:ext cx="9966960" cy="365760"/>
-          </a:xfrm>
-          <a:prstGeom prst="rect">
-            <a:avLst/>
-          </a:prstGeom>
-          <a:noFill/>
-          <a:ln/>
-        </p:spPr>
-        <p:txBody>
-          <a:bodyPr wrap="square" lIns="0" tIns="0" rIns="0" bIns="0" rtlCol="0" anchor="ctr"/>
-          <a:lstStyle/>
-          <a:p>
-            <a:pPr indent="0" marL="0">
-              <a:buNone/>
-            </a:pPr>
-            <a:r>
-              <a:rPr lang="en-US" sz="1700" b="1" dirty="0">
-                <a:solidFill>
-                  <a:srgbClr val="0D1B24"/>
-                </a:solidFill>
-                <a:latin typeface="Arial" pitchFamily="34" charset="0"/>
-                <a:ea typeface="Arial" pitchFamily="34" charset="-122"/>
-                <a:cs typeface="Arial" pitchFamily="34" charset="-120"/>
-              </a:rPr>
-              <a:t>Managed memory &amp; traces</a:t>
-            </a:r>
-            <a:endParaRPr lang="en-US" sz="1700" dirty="0"/>
-          </a:p>
-        </p:txBody>
-      </p:sp>
-      <p:sp>
-        <p:nvSpPr>
-          <p:cNvPr id="7" name="Text 5"/>
-          <p:cNvSpPr/>
-          <p:nvPr/>
-        </p:nvSpPr>
-        <p:spPr>
-          <a:xfrm>
-            <a:off x="1554480" y="2103120"/>
-            <a:ext cx="9966960" cy="502920"/>
-          </a:xfrm>
-          <a:prstGeom prst="rect">
-            <a:avLst/>
-          </a:prstGeom>
-          <a:noFill/>
-          <a:ln/>
-        </p:spPr>
-        <p:txBody>
-          <a:bodyPr wrap="square" lIns="0" tIns="0" rIns="0" bIns="0" rtlCol="0" anchor="ctr"/>
-          <a:lstStyle/>
-          <a:p>
-            <a:pPr indent="0" marL="0">
-              <a:buNone/>
-            </a:pPr>
-            <a:r>
-              <a:rPr lang="en-US" sz="1350" dirty="0">
+            <a:off x="4023360" y="1783080"/>
+            <a:ext cx="7589520" cy="594360"/>
+          </a:xfrm>
+          <a:prstGeom prst="rect">
+            <a:avLst/>
+          </a:prstGeom>
+          <a:noFill/>
+          <a:ln/>
+        </p:spPr>
+        <p:txBody>
+          <a:bodyPr wrap="square" lIns="0" tIns="0" rIns="0" bIns="0" rtlCol="0" anchor="ctr"/>
+          <a:lstStyle/>
+          <a:p>
+            <a:pPr indent="0" marL="0">
+              <a:buNone/>
+            </a:pPr>
+            <a:r>
+              <a:rPr lang="en-US" sz="1300" dirty="0">
                 <a:solidFill>
                   <a:srgbClr val="5C6E7A"/>
                 </a:solidFill>
@@ -6664,21 +7468,21 @@
                 <a:ea typeface="Arial" pitchFamily="34" charset="-122"/>
                 <a:cs typeface="Arial" pitchFamily="34" charset="-120"/>
               </a:rPr>
-              <a:t>Qdrant and ClickHouse in the cloud — vector memory and Langfuse traces that outlive any single machine.</a:t>
-            </a:r>
-            <a:endParaRPr lang="en-US" sz="1350" dirty="0"/>
-          </a:p>
-        </p:txBody>
-      </p:sp>
-      <p:sp>
-        <p:nvSpPr>
-          <p:cNvPr id="8" name="Shape 6"/>
-          <p:cNvSpPr/>
-          <p:nvPr/>
-        </p:nvSpPr>
-        <p:spPr>
-          <a:xfrm>
-            <a:off x="548640" y="2715768"/>
+              <a:t>Live assistant turn (2026-10-22): craft review delivered, LLM-judge verdict recorded — queryable via job-status.</a:t>
+            </a:r>
+            <a:endParaRPr lang="en-US" sz="1300" dirty="0"/>
+          </a:p>
+        </p:txBody>
+      </p:sp>
+      <p:sp>
+        <p:nvSpPr>
+          <p:cNvPr id="7" name="Shape 5"/>
+          <p:cNvSpPr/>
+          <p:nvPr/>
+        </p:nvSpPr>
+        <p:spPr>
+          <a:xfrm>
+            <a:off x="548640" y="2542032"/>
             <a:ext cx="11091672" cy="0"/>
           </a:xfrm>
           <a:prstGeom prst="line">
@@ -6695,108 +7499,69 @@
       </p:sp>
       <p:sp>
         <p:nvSpPr>
+          <p:cNvPr id="8" name="Text 6"/>
+          <p:cNvSpPr/>
+          <p:nvPr/>
+        </p:nvSpPr>
+        <p:spPr>
+          <a:xfrm>
+            <a:off x="548640" y="2651760"/>
+            <a:ext cx="3291840" cy="365760"/>
+          </a:xfrm>
+          <a:prstGeom prst="rect">
+            <a:avLst/>
+          </a:prstGeom>
+          <a:noFill/>
+          <a:ln/>
+        </p:spPr>
+        <p:txBody>
+          <a:bodyPr wrap="square" lIns="0" tIns="0" rIns="0" bIns="0" rtlCol="0" anchor="ctr"/>
+          <a:lstStyle/>
+          <a:p>
+            <a:pPr indent="0" marL="0">
+              <a:buNone/>
+            </a:pPr>
+            <a:r>
+              <a:rPr lang="en-US" sz="1450" b="1" dirty="0">
+                <a:solidFill>
+                  <a:srgbClr val="083F45"/>
+                </a:solidFill>
+                <a:latin typeface="Courier New" pitchFamily="34" charset="0"/>
+                <a:ea typeface="Courier New" pitchFamily="34" charset="-122"/>
+                <a:cs typeface="Courier New" pitchFamily="34" charset="-120"/>
+              </a:rPr>
+              <a:t>docker ps</a:t>
+            </a:r>
+            <a:endParaRPr lang="en-US" sz="1450" dirty="0"/>
+          </a:p>
+        </p:txBody>
+      </p:sp>
+      <p:sp>
+        <p:nvSpPr>
           <p:cNvPr id="9" name="Text 7"/>
           <p:cNvSpPr/>
           <p:nvPr/>
         </p:nvSpPr>
         <p:spPr>
           <a:xfrm>
-            <a:off x="548640" y="2871216"/>
-            <a:ext cx="731520" cy="777240"/>
-          </a:xfrm>
-          <a:prstGeom prst="rect">
-            <a:avLst/>
-          </a:prstGeom>
-          <a:noFill/>
-          <a:ln/>
-        </p:spPr>
-        <p:txBody>
-          <a:bodyPr wrap="square" lIns="0" tIns="0" rIns="0" bIns="0" rtlCol="0" anchor="ctr"/>
-          <a:lstStyle/>
-          <a:p>
-            <a:pPr indent="0" marL="0">
-              <a:buNone/>
-            </a:pPr>
-            <a:r>
-              <a:rPr lang="en-US" sz="4000" b="1" dirty="0">
-                <a:solidFill>
-                  <a:srgbClr val="0B5D66"/>
-                </a:solidFill>
-                <a:latin typeface="Arial" pitchFamily="34" charset="0"/>
-                <a:ea typeface="Arial" pitchFamily="34" charset="-122"/>
-                <a:cs typeface="Arial" pitchFamily="34" charset="-120"/>
-              </a:rPr>
-              <a:t>2</a:t>
-            </a:r>
-            <a:endParaRPr lang="en-US" sz="4000" dirty="0"/>
-          </a:p>
-        </p:txBody>
-      </p:sp>
-      <p:sp>
-        <p:nvSpPr>
-          <p:cNvPr id="10" name="Text 8"/>
-          <p:cNvSpPr/>
-          <p:nvPr/>
-        </p:nvSpPr>
-        <p:spPr>
-          <a:xfrm>
-            <a:off x="1554480" y="2843784"/>
-            <a:ext cx="9966960" cy="365760"/>
-          </a:xfrm>
-          <a:prstGeom prst="rect">
-            <a:avLst/>
-          </a:prstGeom>
-          <a:noFill/>
-          <a:ln/>
-        </p:spPr>
-        <p:txBody>
-          <a:bodyPr wrap="square" lIns="0" tIns="0" rIns="0" bIns="0" rtlCol="0" anchor="ctr"/>
-          <a:lstStyle/>
-          <a:p>
-            <a:pPr indent="0" marL="0">
-              <a:buNone/>
-            </a:pPr>
-            <a:r>
-              <a:rPr lang="en-US" sz="1700" b="1" dirty="0">
-                <a:solidFill>
-                  <a:srgbClr val="0D1B24"/>
-                </a:solidFill>
-                <a:latin typeface="Arial" pitchFamily="34" charset="0"/>
-                <a:ea typeface="Arial" pitchFamily="34" charset="-122"/>
-                <a:cs typeface="Arial" pitchFamily="34" charset="-120"/>
-              </a:rPr>
-              <a:t>GPU nodes</a:t>
-            </a:r>
-            <a:endParaRPr lang="en-US" sz="1700" dirty="0"/>
-          </a:p>
-        </p:txBody>
-      </p:sp>
-      <p:sp>
-        <p:nvSpPr>
-          <p:cNvPr id="11" name="Text 9"/>
-          <p:cNvSpPr/>
-          <p:nvPr/>
-        </p:nvSpPr>
-        <p:spPr>
-          <a:xfrm>
-            <a:off x="1554480" y="3236976"/>
-            <a:ext cx="9966960" cy="502920"/>
-          </a:xfrm>
-          <a:prstGeom prst="rect">
-            <a:avLst/>
-          </a:prstGeom>
-          <a:noFill/>
-          <a:ln/>
-        </p:spPr>
-        <p:txBody>
-          <a:bodyPr wrap="square" lIns="0" tIns="0" rIns="0" bIns="0" rtlCol="0" anchor="ctr"/>
-          <a:lstStyle/>
-          <a:p>
-            <a:pPr indent="0" marL="0">
-              <a:buNone/>
-            </a:pPr>
-            <a:r>
-              <a:rPr lang="en-US" sz="1350" dirty="0">
+            <a:off x="4023360" y="2651760"/>
+            <a:ext cx="7589520" cy="594360"/>
+          </a:xfrm>
+          <a:prstGeom prst="rect">
+            <a:avLst/>
+          </a:prstGeom>
+          <a:noFill/>
+          <a:ln/>
+        </p:spPr>
+        <p:txBody>
+          <a:bodyPr wrap="square" lIns="0" tIns="0" rIns="0" bIns="0" rtlCol="0" anchor="ctr"/>
+          <a:lstStyle/>
+          <a:p>
+            <a:pPr indent="0" marL="0">
+              <a:buNone/>
+            </a:pPr>
+            <a:r>
+              <a:rPr lang="en-US" sz="1300" dirty="0">
                 <a:solidFill>
                   <a:srgbClr val="5C6E7A"/>
                 </a:solidFill>
@@ -6804,21 +7569,21 @@
                 <a:ea typeface="Arial" pitchFamily="34" charset="-122"/>
                 <a:cs typeface="Arial" pitchFamily="34" charset="-120"/>
               </a:rPr>
-              <a:t>Voice mentors and model work beyond the local MLX bench — realtime speech needs real GPUs.</a:t>
-            </a:r>
-            <a:endParaRPr lang="en-US" sz="1350" dirty="0"/>
-          </a:p>
-        </p:txBody>
-      </p:sp>
-      <p:sp>
-        <p:nvSpPr>
-          <p:cNvPr id="12" name="Shape 10"/>
-          <p:cNvSpPr/>
-          <p:nvPr/>
-        </p:nvSpPr>
-        <p:spPr>
-          <a:xfrm>
-            <a:off x="548640" y="3849624"/>
+              <a:t>44 containers up incl. dota-copilot-portal, dota-premium-mcp, knowledge / hippocampus / modality workers — 2026-10-21.</a:t>
+            </a:r>
+            <a:endParaRPr lang="en-US" sz="1300" dirty="0"/>
+          </a:p>
+        </p:txBody>
+      </p:sp>
+      <p:sp>
+        <p:nvSpPr>
+          <p:cNvPr id="10" name="Shape 8"/>
+          <p:cNvSpPr/>
+          <p:nvPr/>
+        </p:nvSpPr>
+        <p:spPr>
+          <a:xfrm>
+            <a:off x="548640" y="3410712"/>
             <a:ext cx="11091672" cy="0"/>
           </a:xfrm>
           <a:prstGeom prst="line">
@@ -6835,108 +7600,69 @@
       </p:sp>
       <p:sp>
         <p:nvSpPr>
-          <p:cNvPr id="13" name="Text 11"/>
-          <p:cNvSpPr/>
-          <p:nvPr/>
-        </p:nvSpPr>
-        <p:spPr>
-          <a:xfrm>
-            <a:off x="548640" y="4005072"/>
-            <a:ext cx="731520" cy="777240"/>
-          </a:xfrm>
-          <a:prstGeom prst="rect">
-            <a:avLst/>
-          </a:prstGeom>
-          <a:noFill/>
-          <a:ln/>
-        </p:spPr>
-        <p:txBody>
-          <a:bodyPr wrap="square" lIns="0" tIns="0" rIns="0" bIns="0" rtlCol="0" anchor="ctr"/>
-          <a:lstStyle/>
-          <a:p>
-            <a:pPr indent="0" marL="0">
-              <a:buNone/>
-            </a:pPr>
-            <a:r>
-              <a:rPr lang="en-US" sz="4000" b="1" dirty="0">
-                <a:solidFill>
-                  <a:srgbClr val="D97706"/>
-                </a:solidFill>
-                <a:latin typeface="Arial" pitchFamily="34" charset="0"/>
-                <a:ea typeface="Arial" pitchFamily="34" charset="-122"/>
-                <a:cs typeface="Arial" pitchFamily="34" charset="-120"/>
-              </a:rPr>
-              <a:t>3</a:t>
-            </a:r>
-            <a:endParaRPr lang="en-US" sz="4000" dirty="0"/>
-          </a:p>
-        </p:txBody>
-      </p:sp>
-      <p:sp>
-        <p:nvSpPr>
-          <p:cNvPr id="14" name="Text 12"/>
-          <p:cNvSpPr/>
-          <p:nvPr/>
-        </p:nvSpPr>
-        <p:spPr>
-          <a:xfrm>
-            <a:off x="1554480" y="3977640"/>
-            <a:ext cx="9966960" cy="365760"/>
-          </a:xfrm>
-          <a:prstGeom prst="rect">
-            <a:avLst/>
-          </a:prstGeom>
-          <a:noFill/>
-          <a:ln/>
-        </p:spPr>
-        <p:txBody>
-          <a:bodyPr wrap="square" lIns="0" tIns="0" rIns="0" bIns="0" rtlCol="0" anchor="ctr"/>
-          <a:lstStyle/>
-          <a:p>
-            <a:pPr indent="0" marL="0">
-              <a:buNone/>
-            </a:pPr>
-            <a:r>
-              <a:rPr lang="en-US" sz="1700" b="1" dirty="0">
-                <a:solidFill>
-                  <a:srgbClr val="0D1B24"/>
-                </a:solidFill>
-                <a:latin typeface="Arial" pitchFamily="34" charset="0"/>
-                <a:ea typeface="Arial" pitchFamily="34" charset="-122"/>
-                <a:cs typeface="Arial" pitchFamily="34" charset="-120"/>
-              </a:rPr>
-              <a:t>Public Mentor API</a:t>
-            </a:r>
-            <a:endParaRPr lang="en-US" sz="1700" dirty="0"/>
-          </a:p>
-        </p:txBody>
-      </p:sp>
-      <p:sp>
-        <p:nvSpPr>
-          <p:cNvPr id="15" name="Text 13"/>
-          <p:cNvSpPr/>
-          <p:nvPr/>
-        </p:nvSpPr>
-        <p:spPr>
-          <a:xfrm>
-            <a:off x="1554480" y="4370832"/>
-            <a:ext cx="9966960" cy="502920"/>
-          </a:xfrm>
-          <a:prstGeom prst="rect">
-            <a:avLst/>
-          </a:prstGeom>
-          <a:noFill/>
-          <a:ln/>
-        </p:spPr>
-        <p:txBody>
-          <a:bodyPr wrap="square" lIns="0" tIns="0" rIns="0" bIns="0" rtlCol="0" anchor="ctr"/>
-          <a:lstStyle/>
-          <a:p>
-            <a:pPr indent="0" marL="0">
-              <a:buNone/>
-            </a:pPr>
-            <a:r>
-              <a:rPr lang="en-US" sz="1350" dirty="0">
+          <p:cNvPr id="11" name="Text 9"/>
+          <p:cNvSpPr/>
+          <p:nvPr/>
+        </p:nvSpPr>
+        <p:spPr>
+          <a:xfrm>
+            <a:off x="548640" y="3520440"/>
+            <a:ext cx="3291840" cy="365760"/>
+          </a:xfrm>
+          <a:prstGeom prst="rect">
+            <a:avLst/>
+          </a:prstGeom>
+          <a:noFill/>
+          <a:ln/>
+        </p:spPr>
+        <p:txBody>
+          <a:bodyPr wrap="square" lIns="0" tIns="0" rIns="0" bIns="0" rtlCol="0" anchor="ctr"/>
+          <a:lstStyle/>
+          <a:p>
+            <a:pPr indent="0" marL="0">
+              <a:buNone/>
+            </a:pPr>
+            <a:r>
+              <a:rPr lang="en-US" sz="1450" b="1" dirty="0">
+                <a:solidFill>
+                  <a:srgbClr val="083F45"/>
+                </a:solidFill>
+                <a:latin typeface="Courier New" pitchFamily="34" charset="0"/>
+                <a:ea typeface="Courier New" pitchFamily="34" charset="-122"/>
+                <a:cs typeface="Courier New" pitchFamily="34" charset="-120"/>
+              </a:rPr>
+              <a:t>go-mentor.mind.glass</a:t>
+            </a:r>
+            <a:endParaRPr lang="en-US" sz="1450" dirty="0"/>
+          </a:p>
+        </p:txBody>
+      </p:sp>
+      <p:sp>
+        <p:nvSpPr>
+          <p:cNvPr id="12" name="Text 10"/>
+          <p:cNvSpPr/>
+          <p:nvPr/>
+        </p:nvSpPr>
+        <p:spPr>
+          <a:xfrm>
+            <a:off x="4023360" y="3520440"/>
+            <a:ext cx="7589520" cy="594360"/>
+          </a:xfrm>
+          <a:prstGeom prst="rect">
+            <a:avLst/>
+          </a:prstGeom>
+          <a:noFill/>
+          <a:ln/>
+        </p:spPr>
+        <p:txBody>
+          <a:bodyPr wrap="square" lIns="0" tIns="0" rIns="0" bIns="0" rtlCol="0" anchor="ctr"/>
+          <a:lstStyle/>
+          <a:p>
+            <a:pPr indent="0" marL="0">
+              <a:buNone/>
+            </a:pPr>
+            <a:r>
+              <a:rPr lang="en-US" sz="1300" dirty="0">
                 <a:solidFill>
                   <a:srgbClr val="5C6E7A"/>
                 </a:solidFill>
@@ -6944,21 +7670,21 @@
                 <a:ea typeface="Arial" pitchFamily="34" charset="-122"/>
                 <a:cs typeface="Arial" pitchFamily="34" charset="-120"/>
               </a:rPr>
-              <a:t>Take Mentor as a Service multi-tenant: pilot customers, billing, SLAs. The monetizing step.</a:t>
-            </a:r>
-            <a:endParaRPr lang="en-US" sz="1350" dirty="0"/>
-          </a:p>
-        </p:txBody>
-      </p:sp>
-      <p:sp>
-        <p:nvSpPr>
-          <p:cNvPr id="16" name="Shape 14"/>
-          <p:cNvSpPr/>
-          <p:nvPr/>
-        </p:nvSpPr>
-        <p:spPr>
-          <a:xfrm>
-            <a:off x="548640" y="4983480"/>
+              <a:t>Live coding mentor running on the runtime: student goals → verified outcomes, not a mockup.</a:t>
+            </a:r>
+            <a:endParaRPr lang="en-US" sz="1300" dirty="0"/>
+          </a:p>
+        </p:txBody>
+      </p:sp>
+      <p:sp>
+        <p:nvSpPr>
+          <p:cNvPr id="13" name="Shape 11"/>
+          <p:cNvSpPr/>
+          <p:nvPr/>
+        </p:nvSpPr>
+        <p:spPr>
+          <a:xfrm>
+            <a:off x="548640" y="4279392"/>
             <a:ext cx="11091672" cy="0"/>
           </a:xfrm>
           <a:prstGeom prst="line">
@@ -6975,40 +7701,141 @@
       </p:sp>
       <p:sp>
         <p:nvSpPr>
+          <p:cNvPr id="14" name="Text 12"/>
+          <p:cNvSpPr/>
+          <p:nvPr/>
+        </p:nvSpPr>
+        <p:spPr>
+          <a:xfrm>
+            <a:off x="548640" y="4389120"/>
+            <a:ext cx="3291840" cy="365760"/>
+          </a:xfrm>
+          <a:prstGeom prst="rect">
+            <a:avLst/>
+          </a:prstGeom>
+          <a:noFill/>
+          <a:ln/>
+        </p:spPr>
+        <p:txBody>
+          <a:bodyPr wrap="square" lIns="0" tIns="0" rIns="0" bIns="0" rtlCol="0" anchor="ctr"/>
+          <a:lstStyle/>
+          <a:p>
+            <a:pPr indent="0" marL="0">
+              <a:buNone/>
+            </a:pPr>
+            <a:r>
+              <a:rPr lang="en-US" sz="1450" b="1" dirty="0">
+                <a:solidFill>
+                  <a:srgbClr val="083F45"/>
+                </a:solidFill>
+                <a:latin typeface="Courier New" pitchFamily="34" charset="0"/>
+                <a:ea typeface="Courier New" pitchFamily="34" charset="-122"/>
+                <a:cs typeface="Courier New" pitchFamily="34" charset="-120"/>
+              </a:rPr>
+              <a:t>deck.mind.glass</a:t>
+            </a:r>
+            <a:endParaRPr lang="en-US" sz="1450" dirty="0"/>
+          </a:p>
+        </p:txBody>
+      </p:sp>
+      <p:sp>
+        <p:nvSpPr>
+          <p:cNvPr id="15" name="Text 13"/>
+          <p:cNvSpPr/>
+          <p:nvPr/>
+        </p:nvSpPr>
+        <p:spPr>
+          <a:xfrm>
+            <a:off x="4023360" y="4389120"/>
+            <a:ext cx="7589520" cy="594360"/>
+          </a:xfrm>
+          <a:prstGeom prst="rect">
+            <a:avLst/>
+          </a:prstGeom>
+          <a:noFill/>
+          <a:ln/>
+        </p:spPr>
+        <p:txBody>
+          <a:bodyPr wrap="square" lIns="0" tIns="0" rIns="0" bIns="0" rtlCol="0" anchor="ctr"/>
+          <a:lstStyle/>
+          <a:p>
+            <a:pPr indent="0" marL="0">
+              <a:buNone/>
+            </a:pPr>
+            <a:r>
+              <a:rPr lang="en-US" sz="1300" dirty="0">
+                <a:solidFill>
+                  <a:srgbClr val="5C6E7A"/>
+                </a:solidFill>
+                <a:latin typeface="Arial" pitchFamily="34" charset="0"/>
+                <a:ea typeface="Arial" pitchFamily="34" charset="-122"/>
+                <a:cs typeface="Arial" pitchFamily="34" charset="-120"/>
+              </a:rPr>
+              <a:t>This deck deployed as a live artifact; source PDF in github.com/tdesc/colony-ai-deck.</a:t>
+            </a:r>
+            <a:endParaRPr lang="en-US" sz="1300" dirty="0"/>
+          </a:p>
+        </p:txBody>
+      </p:sp>
+      <p:sp>
+        <p:nvSpPr>
+          <p:cNvPr id="16" name="Shape 14"/>
+          <p:cNvSpPr/>
+          <p:nvPr/>
+        </p:nvSpPr>
+        <p:spPr>
+          <a:xfrm>
+            <a:off x="548640" y="5148072"/>
+            <a:ext cx="11091672" cy="0"/>
+          </a:xfrm>
+          <a:prstGeom prst="line">
+            <a:avLst/>
+          </a:prstGeom>
+          <a:noFill/>
+          <a:ln w="12700">
+            <a:solidFill>
+              <a:srgbClr val="D5DEE2"/>
+            </a:solidFill>
+            <a:prstDash val="solid"/>
+          </a:ln>
+        </p:spPr>
+      </p:sp>
+      <p:sp>
+        <p:nvSpPr>
           <p:cNvPr id="17" name="Text 15"/>
           <p:cNvSpPr/>
           <p:nvPr/>
         </p:nvSpPr>
         <p:spPr>
           <a:xfrm>
-            <a:off x="548640" y="5138928"/>
-            <a:ext cx="731520" cy="777240"/>
-          </a:xfrm>
-          <a:prstGeom prst="rect">
-            <a:avLst/>
-          </a:prstGeom>
-          <a:noFill/>
-          <a:ln/>
-        </p:spPr>
-        <p:txBody>
-          <a:bodyPr wrap="square" lIns="0" tIns="0" rIns="0" bIns="0" rtlCol="0" anchor="ctr"/>
-          <a:lstStyle/>
-          <a:p>
-            <a:pPr indent="0" marL="0">
-              <a:buNone/>
-            </a:pPr>
-            <a:r>
-              <a:rPr lang="en-US" sz="4000" b="1" dirty="0">
-                <a:solidFill>
-                  <a:srgbClr val="0B5D66"/>
-                </a:solidFill>
-                <a:latin typeface="Arial" pitchFamily="34" charset="0"/>
-                <a:ea typeface="Arial" pitchFamily="34" charset="-122"/>
-                <a:cs typeface="Arial" pitchFamily="34" charset="-120"/>
-              </a:rPr>
-              <a:t>4</a:t>
-            </a:r>
-            <a:endParaRPr lang="en-US" sz="4000" dirty="0"/>
+            <a:off x="548640" y="5257800"/>
+            <a:ext cx="3291840" cy="365760"/>
+          </a:xfrm>
+          <a:prstGeom prst="rect">
+            <a:avLst/>
+          </a:prstGeom>
+          <a:noFill/>
+          <a:ln/>
+        </p:spPr>
+        <p:txBody>
+          <a:bodyPr wrap="square" lIns="0" tIns="0" rIns="0" bIns="0" rtlCol="0" anchor="ctr"/>
+          <a:lstStyle/>
+          <a:p>
+            <a:pPr indent="0" marL="0">
+              <a:buNone/>
+            </a:pPr>
+            <a:r>
+              <a:rPr lang="en-US" sz="1450" b="1" dirty="0">
+                <a:solidFill>
+                  <a:srgbClr val="083F45"/>
+                </a:solidFill>
+                <a:latin typeface="Courier New" pitchFamily="34" charset="0"/>
+                <a:ea typeface="Courier New" pitchFamily="34" charset="-122"/>
+                <a:cs typeface="Courier New" pitchFamily="34" charset="-120"/>
+              </a:rPr>
+              <a:t>Langfuse + Qdrant</a:t>
+            </a:r>
+            <a:endParaRPr lang="en-US" sz="1450" dirty="0"/>
           </a:p>
         </p:txBody>
       </p:sp>
@@ -7020,79 +7847,40 @@
         </p:nvSpPr>
         <p:spPr>
           <a:xfrm>
-            <a:off x="1554480" y="5111496"/>
-            <a:ext cx="9966960" cy="365760"/>
-          </a:xfrm>
-          <a:prstGeom prst="rect">
-            <a:avLst/>
-          </a:prstGeom>
-          <a:noFill/>
-          <a:ln/>
-        </p:spPr>
-        <p:txBody>
-          <a:bodyPr wrap="square" lIns="0" tIns="0" rIns="0" bIns="0" rtlCol="0" anchor="ctr"/>
-          <a:lstStyle/>
-          <a:p>
-            <a:pPr indent="0" marL="0">
-              <a:buNone/>
-            </a:pPr>
-            <a:r>
-              <a:rPr lang="en-US" sz="1700" b="1" dirty="0">
-                <a:solidFill>
-                  <a:srgbClr val="0D1B24"/>
-                </a:solidFill>
-                <a:latin typeface="Arial" pitchFamily="34" charset="0"/>
-                <a:ea typeface="Arial" pitchFamily="34" charset="-122"/>
-                <a:cs typeface="Arial" pitchFamily="34" charset="-120"/>
-              </a:rPr>
-              <a:t>Always-on fleet</a:t>
-            </a:r>
-            <a:endParaRPr lang="en-US" sz="1700" dirty="0"/>
+            <a:off x="4023360" y="5257800"/>
+            <a:ext cx="7589520" cy="594360"/>
+          </a:xfrm>
+          <a:prstGeom prst="rect">
+            <a:avLst/>
+          </a:prstGeom>
+          <a:noFill/>
+          <a:ln/>
+        </p:spPr>
+        <p:txBody>
+          <a:bodyPr wrap="square" lIns="0" tIns="0" rIns="0" bIns="0" rtlCol="0" anchor="ctr"/>
+          <a:lstStyle/>
+          <a:p>
+            <a:pPr indent="0" marL="0">
+              <a:buNone/>
+            </a:pPr>
+            <a:r>
+              <a:rPr lang="en-US" sz="1300" dirty="0">
+                <a:solidFill>
+                  <a:srgbClr val="5C6E7A"/>
+                </a:solidFill>
+                <a:latin typeface="Arial" pitchFamily="34" charset="0"/>
+                <a:ea typeface="Arial" pitchFamily="34" charset="-122"/>
+                <a:cs typeface="Arial" pitchFamily="34" charset="-120"/>
+              </a:rPr>
+              <a:t>467K vectors, 161K code chunks, per-session traces — on the founder's box; walkthrough on request.</a:t>
+            </a:r>
+            <a:endParaRPr lang="en-US" sz="1300" dirty="0"/>
           </a:p>
         </p:txBody>
       </p:sp>
       <p:sp>
         <p:nvSpPr>
           <p:cNvPr id="19" name="Text 17"/>
-          <p:cNvSpPr/>
-          <p:nvPr/>
-        </p:nvSpPr>
-        <p:spPr>
-          <a:xfrm>
-            <a:off x="1554480" y="5504688"/>
-            <a:ext cx="9966960" cy="502920"/>
-          </a:xfrm>
-          <a:prstGeom prst="rect">
-            <a:avLst/>
-          </a:prstGeom>
-          <a:noFill/>
-          <a:ln/>
-        </p:spPr>
-        <p:txBody>
-          <a:bodyPr wrap="square" lIns="0" tIns="0" rIns="0" bIns="0" rtlCol="0" anchor="ctr"/>
-          <a:lstStyle/>
-          <a:p>
-            <a:pPr indent="0" marL="0">
-              <a:buNone/>
-            </a:pPr>
-            <a:r>
-              <a:rPr lang="en-US" sz="1350" dirty="0">
-                <a:solidFill>
-                  <a:srgbClr val="5C6E7A"/>
-                </a:solidFill>
-                <a:latin typeface="Arial" pitchFamily="34" charset="0"/>
-                <a:ea typeface="Arial" pitchFamily="34" charset="-122"/>
-                <a:cs typeface="Arial" pitchFamily="34" charset="-120"/>
-              </a:rPr>
-              <a:t>Multi-region Temporal and 24/7 uptime — live mentor sessions that never sleep.</a:t>
-            </a:r>
-            <a:endParaRPr lang="en-US" sz="1350" dirty="0"/>
-          </a:p>
-        </p:txBody>
-      </p:sp>
-      <p:sp>
-        <p:nvSpPr>
-          <p:cNvPr id="20" name="Text 18"/>
           <p:cNvSpPr/>
           <p:nvPr/>
         </p:nvSpPr>
@@ -7123,7 +7911,7 @@
                 <a:ea typeface="Arial" pitchFamily="34" charset="-122"/>
                 <a:cs typeface="Arial" pitchFamily="34" charset="-120"/>
               </a:rPr>
-              <a:t>Credits go to infrastructure, not headcount: memory, GPUs, uptime.</a:t>
+              <a:t>Every artifact is checkable today — ask for a live walkthrough in the call.</a:t>
             </a:r>
             <a:endParaRPr lang="en-US" sz="1200" dirty="0"/>
           </a:p>
@@ -7194,7 +7982,7 @@
                 <a:ea typeface="Arial" pitchFamily="34" charset="-122"/>
                 <a:cs typeface="Arial" pitchFamily="34" charset="-120"/>
               </a:rPr>
-              <a:t>ROADMAP</a:t>
+              <a:t>THE ASK · CLOUD CREDITS</a:t>
             </a:r>
             <a:endParaRPr lang="en-US" sz="1200" dirty="0"/>
           </a:p>
@@ -7233,7 +8021,7 @@
                 <a:ea typeface="Arial" pitchFamily="34" charset="-122"/>
                 <a:cs typeface="Arial" pitchFamily="34" charset="-120"/>
               </a:rPr>
-              <a:t>From working prototype to hosted runtime.</a:t>
+              <a:t>≈$50K in credits. 12 months. One beachhead.</a:t>
             </a:r>
             <a:endParaRPr lang="en-US" sz="3000" dirty="0"/>
           </a:p>
@@ -7247,14 +8035,420 @@
         </p:nvSpPr>
         <p:spPr>
           <a:xfrm>
-            <a:off x="914400" y="3063240"/>
-            <a:ext cx="10332720" cy="0"/>
+            <a:off x="548640" y="1627632"/>
+            <a:ext cx="6126480" cy="0"/>
           </a:xfrm>
           <a:prstGeom prst="line">
             <a:avLst/>
           </a:prstGeom>
           <a:noFill/>
-          <a:ln w="25400">
+          <a:ln w="12700">
+            <a:solidFill>
+              <a:srgbClr val="D5DEE2"/>
+            </a:solidFill>
+            <a:prstDash val="solid"/>
+          </a:ln>
+        </p:spPr>
+      </p:sp>
+      <p:sp>
+        <p:nvSpPr>
+          <p:cNvPr id="5" name="Text 3"/>
+          <p:cNvSpPr/>
+          <p:nvPr/>
+        </p:nvSpPr>
+        <p:spPr>
+          <a:xfrm>
+            <a:off x="548640" y="1755648"/>
+            <a:ext cx="5943600" cy="347472"/>
+          </a:xfrm>
+          <a:prstGeom prst="rect">
+            <a:avLst/>
+          </a:prstGeom>
+          <a:noFill/>
+          <a:ln/>
+        </p:spPr>
+        <p:txBody>
+          <a:bodyPr wrap="square" lIns="0" tIns="0" rIns="0" bIns="0" rtlCol="0" anchor="ctr"/>
+          <a:lstStyle/>
+          <a:p>
+            <a:pPr indent="0" marL="0">
+              <a:buNone/>
+            </a:pPr>
+            <a:r>
+              <a:rPr lang="en-US" sz="1650" b="1" dirty="0">
+                <a:solidFill>
+                  <a:srgbClr val="0D1B24"/>
+                </a:solidFill>
+                <a:latin typeface="Arial" pitchFamily="34" charset="0"/>
+                <a:ea typeface="Arial" pitchFamily="34" charset="-122"/>
+                <a:cs typeface="Arial" pitchFamily="34" charset="-120"/>
+              </a:rPr>
+              <a:t>Managed memory &amp; traces</a:t>
+            </a:r>
+            <a:endParaRPr lang="en-US" sz="1650" dirty="0"/>
+          </a:p>
+        </p:txBody>
+      </p:sp>
+      <p:sp>
+        <p:nvSpPr>
+          <p:cNvPr id="6" name="Text 4"/>
+          <p:cNvSpPr/>
+          <p:nvPr/>
+        </p:nvSpPr>
+        <p:spPr>
+          <a:xfrm>
+            <a:off x="548640" y="2121408"/>
+            <a:ext cx="5943600" cy="512064"/>
+          </a:xfrm>
+          <a:prstGeom prst="rect">
+            <a:avLst/>
+          </a:prstGeom>
+          <a:noFill/>
+          <a:ln/>
+        </p:spPr>
+        <p:txBody>
+          <a:bodyPr wrap="square" lIns="0" tIns="0" rIns="0" bIns="0" rtlCol="0" anchor="ctr"/>
+          <a:lstStyle/>
+          <a:p>
+            <a:pPr indent="0" marL="0">
+              <a:buNone/>
+            </a:pPr>
+            <a:r>
+              <a:rPr lang="en-US" sz="1250" dirty="0">
+                <a:solidFill>
+                  <a:srgbClr val="5C6E7A"/>
+                </a:solidFill>
+                <a:latin typeface="Arial" pitchFamily="34" charset="0"/>
+                <a:ea typeface="Arial" pitchFamily="34" charset="-122"/>
+                <a:cs typeface="Arial" pitchFamily="34" charset="-120"/>
+              </a:rPr>
+              <a:t>Qdrant and ClickHouse in the cloud — vector memory and Langfuse traces that outlive any single machine.</a:t>
+            </a:r>
+            <a:endParaRPr lang="en-US" sz="1250" dirty="0"/>
+          </a:p>
+        </p:txBody>
+      </p:sp>
+      <p:sp>
+        <p:nvSpPr>
+          <p:cNvPr id="7" name="Shape 5"/>
+          <p:cNvSpPr/>
+          <p:nvPr/>
+        </p:nvSpPr>
+        <p:spPr>
+          <a:xfrm>
+            <a:off x="548640" y="2743200"/>
+            <a:ext cx="6126480" cy="0"/>
+          </a:xfrm>
+          <a:prstGeom prst="line">
+            <a:avLst/>
+          </a:prstGeom>
+          <a:noFill/>
+          <a:ln w="12700">
+            <a:solidFill>
+              <a:srgbClr val="D5DEE2"/>
+            </a:solidFill>
+            <a:prstDash val="solid"/>
+          </a:ln>
+        </p:spPr>
+      </p:sp>
+      <p:sp>
+        <p:nvSpPr>
+          <p:cNvPr id="8" name="Text 6"/>
+          <p:cNvSpPr/>
+          <p:nvPr/>
+        </p:nvSpPr>
+        <p:spPr>
+          <a:xfrm>
+            <a:off x="548640" y="2871216"/>
+            <a:ext cx="5943600" cy="347472"/>
+          </a:xfrm>
+          <a:prstGeom prst="rect">
+            <a:avLst/>
+          </a:prstGeom>
+          <a:noFill/>
+          <a:ln/>
+        </p:spPr>
+        <p:txBody>
+          <a:bodyPr wrap="square" lIns="0" tIns="0" rIns="0" bIns="0" rtlCol="0" anchor="ctr"/>
+          <a:lstStyle/>
+          <a:p>
+            <a:pPr indent="0" marL="0">
+              <a:buNone/>
+            </a:pPr>
+            <a:r>
+              <a:rPr lang="en-US" sz="1650" b="1" dirty="0">
+                <a:solidFill>
+                  <a:srgbClr val="0D1B24"/>
+                </a:solidFill>
+                <a:latin typeface="Arial" pitchFamily="34" charset="0"/>
+                <a:ea typeface="Arial" pitchFamily="34" charset="-122"/>
+                <a:cs typeface="Arial" pitchFamily="34" charset="-120"/>
+              </a:rPr>
+              <a:t>GPU nodes</a:t>
+            </a:r>
+            <a:endParaRPr lang="en-US" sz="1650" dirty="0"/>
+          </a:p>
+        </p:txBody>
+      </p:sp>
+      <p:sp>
+        <p:nvSpPr>
+          <p:cNvPr id="9" name="Text 7"/>
+          <p:cNvSpPr/>
+          <p:nvPr/>
+        </p:nvSpPr>
+        <p:spPr>
+          <a:xfrm>
+            <a:off x="548640" y="3236976"/>
+            <a:ext cx="5943600" cy="512064"/>
+          </a:xfrm>
+          <a:prstGeom prst="rect">
+            <a:avLst/>
+          </a:prstGeom>
+          <a:noFill/>
+          <a:ln/>
+        </p:spPr>
+        <p:txBody>
+          <a:bodyPr wrap="square" lIns="0" tIns="0" rIns="0" bIns="0" rtlCol="0" anchor="ctr"/>
+          <a:lstStyle/>
+          <a:p>
+            <a:pPr indent="0" marL="0">
+              <a:buNone/>
+            </a:pPr>
+            <a:r>
+              <a:rPr lang="en-US" sz="1250" dirty="0">
+                <a:solidFill>
+                  <a:srgbClr val="5C6E7A"/>
+                </a:solidFill>
+                <a:latin typeface="Arial" pitchFamily="34" charset="0"/>
+                <a:ea typeface="Arial" pitchFamily="34" charset="-122"/>
+                <a:cs typeface="Arial" pitchFamily="34" charset="-120"/>
+              </a:rPr>
+              <a:t>Voice mentors and model work beyond the local MLX bench — realtime speech needs real GPUs.</a:t>
+            </a:r>
+            <a:endParaRPr lang="en-US" sz="1250" dirty="0"/>
+          </a:p>
+        </p:txBody>
+      </p:sp>
+      <p:sp>
+        <p:nvSpPr>
+          <p:cNvPr id="10" name="Shape 8"/>
+          <p:cNvSpPr/>
+          <p:nvPr/>
+        </p:nvSpPr>
+        <p:spPr>
+          <a:xfrm>
+            <a:off x="548640" y="3858768"/>
+            <a:ext cx="6126480" cy="0"/>
+          </a:xfrm>
+          <a:prstGeom prst="line">
+            <a:avLst/>
+          </a:prstGeom>
+          <a:noFill/>
+          <a:ln w="12700">
+            <a:solidFill>
+              <a:srgbClr val="D5DEE2"/>
+            </a:solidFill>
+            <a:prstDash val="solid"/>
+          </a:ln>
+        </p:spPr>
+      </p:sp>
+      <p:sp>
+        <p:nvSpPr>
+          <p:cNvPr id="11" name="Text 9"/>
+          <p:cNvSpPr/>
+          <p:nvPr/>
+        </p:nvSpPr>
+        <p:spPr>
+          <a:xfrm>
+            <a:off x="548640" y="3986784"/>
+            <a:ext cx="5943600" cy="347472"/>
+          </a:xfrm>
+          <a:prstGeom prst="rect">
+            <a:avLst/>
+          </a:prstGeom>
+          <a:noFill/>
+          <a:ln/>
+        </p:spPr>
+        <p:txBody>
+          <a:bodyPr wrap="square" lIns="0" tIns="0" rIns="0" bIns="0" rtlCol="0" anchor="ctr"/>
+          <a:lstStyle/>
+          <a:p>
+            <a:pPr indent="0" marL="0">
+              <a:buNone/>
+            </a:pPr>
+            <a:r>
+              <a:rPr lang="en-US" sz="1650" b="1" dirty="0">
+                <a:solidFill>
+                  <a:srgbClr val="0D1B24"/>
+                </a:solidFill>
+                <a:latin typeface="Arial" pitchFamily="34" charset="0"/>
+                <a:ea typeface="Arial" pitchFamily="34" charset="-122"/>
+                <a:cs typeface="Arial" pitchFamily="34" charset="-120"/>
+              </a:rPr>
+              <a:t>Public Mentor API</a:t>
+            </a:r>
+            <a:endParaRPr lang="en-US" sz="1650" dirty="0"/>
+          </a:p>
+        </p:txBody>
+      </p:sp>
+      <p:sp>
+        <p:nvSpPr>
+          <p:cNvPr id="12" name="Text 10"/>
+          <p:cNvSpPr/>
+          <p:nvPr/>
+        </p:nvSpPr>
+        <p:spPr>
+          <a:xfrm>
+            <a:off x="548640" y="4352544"/>
+            <a:ext cx="5943600" cy="512064"/>
+          </a:xfrm>
+          <a:prstGeom prst="rect">
+            <a:avLst/>
+          </a:prstGeom>
+          <a:noFill/>
+          <a:ln/>
+        </p:spPr>
+        <p:txBody>
+          <a:bodyPr wrap="square" lIns="0" tIns="0" rIns="0" bIns="0" rtlCol="0" anchor="ctr"/>
+          <a:lstStyle/>
+          <a:p>
+            <a:pPr indent="0" marL="0">
+              <a:buNone/>
+            </a:pPr>
+            <a:r>
+              <a:rPr lang="en-US" sz="1250" dirty="0">
+                <a:solidFill>
+                  <a:srgbClr val="5C6E7A"/>
+                </a:solidFill>
+                <a:latin typeface="Arial" pitchFamily="34" charset="0"/>
+                <a:ea typeface="Arial" pitchFamily="34" charset="-122"/>
+                <a:cs typeface="Arial" pitchFamily="34" charset="-120"/>
+              </a:rPr>
+              <a:t>Take Mentor as a Service multi-tenant: pilot customers, billing, SLAs. The monetizing step.</a:t>
+            </a:r>
+            <a:endParaRPr lang="en-US" sz="1250" dirty="0"/>
+          </a:p>
+        </p:txBody>
+      </p:sp>
+      <p:sp>
+        <p:nvSpPr>
+          <p:cNvPr id="13" name="Shape 11"/>
+          <p:cNvSpPr/>
+          <p:nvPr/>
+        </p:nvSpPr>
+        <p:spPr>
+          <a:xfrm>
+            <a:off x="548640" y="4974336"/>
+            <a:ext cx="6126480" cy="0"/>
+          </a:xfrm>
+          <a:prstGeom prst="line">
+            <a:avLst/>
+          </a:prstGeom>
+          <a:noFill/>
+          <a:ln w="12700">
+            <a:solidFill>
+              <a:srgbClr val="D5DEE2"/>
+            </a:solidFill>
+            <a:prstDash val="solid"/>
+          </a:ln>
+        </p:spPr>
+      </p:sp>
+      <p:sp>
+        <p:nvSpPr>
+          <p:cNvPr id="14" name="Text 12"/>
+          <p:cNvSpPr/>
+          <p:nvPr/>
+        </p:nvSpPr>
+        <p:spPr>
+          <a:xfrm>
+            <a:off x="548640" y="5102352"/>
+            <a:ext cx="5943600" cy="347472"/>
+          </a:xfrm>
+          <a:prstGeom prst="rect">
+            <a:avLst/>
+          </a:prstGeom>
+          <a:noFill/>
+          <a:ln/>
+        </p:spPr>
+        <p:txBody>
+          <a:bodyPr wrap="square" lIns="0" tIns="0" rIns="0" bIns="0" rtlCol="0" anchor="ctr"/>
+          <a:lstStyle/>
+          <a:p>
+            <a:pPr indent="0" marL="0">
+              <a:buNone/>
+            </a:pPr>
+            <a:r>
+              <a:rPr lang="en-US" sz="1650" b="1" dirty="0">
+                <a:solidFill>
+                  <a:srgbClr val="0D1B24"/>
+                </a:solidFill>
+                <a:latin typeface="Arial" pitchFamily="34" charset="0"/>
+                <a:ea typeface="Arial" pitchFamily="34" charset="-122"/>
+                <a:cs typeface="Arial" pitchFamily="34" charset="-120"/>
+              </a:rPr>
+              <a:t>Always-on fleet</a:t>
+            </a:r>
+            <a:endParaRPr lang="en-US" sz="1650" dirty="0"/>
+          </a:p>
+        </p:txBody>
+      </p:sp>
+      <p:sp>
+        <p:nvSpPr>
+          <p:cNvPr id="15" name="Text 13"/>
+          <p:cNvSpPr/>
+          <p:nvPr/>
+        </p:nvSpPr>
+        <p:spPr>
+          <a:xfrm>
+            <a:off x="548640" y="5468112"/>
+            <a:ext cx="5943600" cy="512064"/>
+          </a:xfrm>
+          <a:prstGeom prst="rect">
+            <a:avLst/>
+          </a:prstGeom>
+          <a:noFill/>
+          <a:ln/>
+        </p:spPr>
+        <p:txBody>
+          <a:bodyPr wrap="square" lIns="0" tIns="0" rIns="0" bIns="0" rtlCol="0" anchor="ctr"/>
+          <a:lstStyle/>
+          <a:p>
+            <a:pPr indent="0" marL="0">
+              <a:buNone/>
+            </a:pPr>
+            <a:r>
+              <a:rPr lang="en-US" sz="1250" dirty="0">
+                <a:solidFill>
+                  <a:srgbClr val="5C6E7A"/>
+                </a:solidFill>
+                <a:latin typeface="Arial" pitchFamily="34" charset="0"/>
+                <a:ea typeface="Arial" pitchFamily="34" charset="-122"/>
+                <a:cs typeface="Arial" pitchFamily="34" charset="-120"/>
+              </a:rPr>
+              <a:t>Multi-region Temporal and 24/7 uptime — live mentor sessions that never sleep.</a:t>
+            </a:r>
+            <a:endParaRPr lang="en-US" sz="1250" dirty="0"/>
+          </a:p>
+        </p:txBody>
+      </p:sp>
+      <p:sp>
+        <p:nvSpPr>
+          <p:cNvPr id="16" name="Shape 14"/>
+          <p:cNvSpPr/>
+          <p:nvPr/>
+        </p:nvSpPr>
+        <p:spPr>
+          <a:xfrm>
+            <a:off x="6949440" y="1627632"/>
+            <a:ext cx="4690872" cy="4297680"/>
+          </a:xfrm>
+          <a:prstGeom prst="rect">
+            <a:avLst/>
+          </a:prstGeom>
+          <a:solidFill>
+            <a:srgbClr val="F4F8F8"/>
+          </a:solidFill>
+          <a:ln w="12700">
             <a:solidFill>
               <a:srgbClr val="C9DADB"/>
             </a:solidFill>
@@ -7264,50 +8458,30 @@
       </p:sp>
       <p:sp>
         <p:nvSpPr>
-          <p:cNvPr id="5" name="Shape 3"/>
-          <p:cNvSpPr/>
-          <p:nvPr/>
-        </p:nvSpPr>
-        <p:spPr>
-          <a:xfrm>
-            <a:off x="868680" y="2944368"/>
-            <a:ext cx="237744" cy="237744"/>
-          </a:xfrm>
-          <a:prstGeom prst="ellipse">
-            <a:avLst/>
-          </a:prstGeom>
-          <a:solidFill>
-            <a:srgbClr val="D97706"/>
-          </a:solidFill>
-          <a:ln/>
-        </p:spPr>
-      </p:sp>
-      <p:sp>
-        <p:nvSpPr>
-          <p:cNvPr id="6" name="Text 4"/>
-          <p:cNvSpPr/>
-          <p:nvPr/>
-        </p:nvSpPr>
-        <p:spPr>
-          <a:xfrm>
-            <a:off x="914400" y="2468880"/>
-            <a:ext cx="2377440" cy="320040"/>
-          </a:xfrm>
-          <a:prstGeom prst="rect">
-            <a:avLst/>
-          </a:prstGeom>
-          <a:noFill/>
-          <a:ln/>
-        </p:spPr>
-        <p:txBody>
-          <a:bodyPr wrap="square" lIns="0" tIns="0" rIns="0" bIns="0" rtlCol="0" anchor="ctr"/>
-          <a:lstStyle/>
-          <a:p>
-            <a:pPr indent="0" marL="0">
-              <a:buNone/>
-            </a:pPr>
-            <a:r>
-              <a:rPr lang="en-US" sz="1500" b="1" spc="100" kern="0" dirty="0">
+          <p:cNvPr id="17" name="Text 15"/>
+          <p:cNvSpPr/>
+          <p:nvPr/>
+        </p:nvSpPr>
+        <p:spPr>
+          <a:xfrm>
+            <a:off x="7223760" y="1828800"/>
+            <a:ext cx="4206240" cy="274320"/>
+          </a:xfrm>
+          <a:prstGeom prst="rect">
+            <a:avLst/>
+          </a:prstGeom>
+          <a:noFill/>
+          <a:ln/>
+        </p:spPr>
+        <p:txBody>
+          <a:bodyPr wrap="square" lIns="0" tIns="0" rIns="0" bIns="0" rtlCol="0" anchor="ctr"/>
+          <a:lstStyle/>
+          <a:p>
+            <a:pPr indent="0" marL="0">
+              <a:buNone/>
+            </a:pPr>
+            <a:r>
+              <a:rPr lang="en-US" sz="1200" b="1" spc="200" kern="0" dirty="0">
                 <a:solidFill>
                   <a:srgbClr val="D97706"/>
                 </a:solidFill>
@@ -7315,7 +8489,46 @@
                 <a:ea typeface="Arial" pitchFamily="34" charset="-122"/>
                 <a:cs typeface="Arial" pitchFamily="34" charset="-120"/>
               </a:rPr>
-              <a:t>NOW</a:t>
+              <a:t>90-DAY MILESTONES</a:t>
+            </a:r>
+            <a:endParaRPr lang="en-US" sz="1200" dirty="0"/>
+          </a:p>
+        </p:txBody>
+      </p:sp>
+      <p:sp>
+        <p:nvSpPr>
+          <p:cNvPr id="18" name="Text 16"/>
+          <p:cNvSpPr/>
+          <p:nvPr/>
+        </p:nvSpPr>
+        <p:spPr>
+          <a:xfrm>
+            <a:off x="7223760" y="2240280"/>
+            <a:ext cx="548640" cy="365760"/>
+          </a:xfrm>
+          <a:prstGeom prst="rect">
+            <a:avLst/>
+          </a:prstGeom>
+          <a:noFill/>
+          <a:ln/>
+        </p:spPr>
+        <p:txBody>
+          <a:bodyPr wrap="square" lIns="0" tIns="0" rIns="0" bIns="0" rtlCol="0" anchor="ctr"/>
+          <a:lstStyle/>
+          <a:p>
+            <a:pPr indent="0" marL="0">
+              <a:buNone/>
+            </a:pPr>
+            <a:r>
+              <a:rPr lang="en-US" sz="1500" b="1" dirty="0">
+                <a:solidFill>
+                  <a:srgbClr val="083F45"/>
+                </a:solidFill>
+                <a:latin typeface="Arial" pitchFamily="34" charset="0"/>
+                <a:ea typeface="Arial" pitchFamily="34" charset="-122"/>
+                <a:cs typeface="Arial" pitchFamily="34" charset="-120"/>
+              </a:rPr>
+              <a:t>M1</a:t>
             </a:r>
             <a:endParaRPr lang="en-US" sz="1500" dirty="0"/>
           </a:p>
@@ -7323,33 +8536,30 @@
       </p:sp>
       <p:sp>
         <p:nvSpPr>
-          <p:cNvPr id="7" name="Text 5"/>
-          <p:cNvSpPr/>
-          <p:nvPr/>
-        </p:nvSpPr>
-        <p:spPr>
-          <a:xfrm>
-            <a:off x="914400" y="3383280"/>
-            <a:ext cx="2514600" cy="1463040"/>
-          </a:xfrm>
-          <a:prstGeom prst="rect">
-            <a:avLst/>
-          </a:prstGeom>
-          <a:noFill/>
-          <a:ln/>
-        </p:spPr>
-        <p:txBody>
-          <a:bodyPr wrap="square" lIns="0" tIns="0" rIns="0" bIns="0" rtlCol="0" anchor="ctr"/>
-          <a:lstStyle/>
-          <a:p>
-            <a:pPr indent="0" marL="0">
-              <a:lnSpc>
-                <a:spcPts val="1800"/>
-              </a:lnSpc>
-              <a:buNone/>
-            </a:pPr>
-            <a:r>
-              <a:rPr lang="en-US" sz="1350" dirty="0">
+          <p:cNvPr id="19" name="Text 17"/>
+          <p:cNvSpPr/>
+          <p:nvPr/>
+        </p:nvSpPr>
+        <p:spPr>
+          <a:xfrm>
+            <a:off x="7818120" y="2240280"/>
+            <a:ext cx="3657600" cy="658368"/>
+          </a:xfrm>
+          <a:prstGeom prst="rect">
+            <a:avLst/>
+          </a:prstGeom>
+          <a:noFill/>
+          <a:ln/>
+        </p:spPr>
+        <p:txBody>
+          <a:bodyPr wrap="square" lIns="0" tIns="0" rIns="0" bIns="0" rtlCol="0" anchor="ctr"/>
+          <a:lstStyle/>
+          <a:p>
+            <a:pPr indent="0" marL="0">
+              <a:buNone/>
+            </a:pPr>
+            <a:r>
+              <a:rPr lang="en-US" sz="1200" dirty="0">
                 <a:solidFill>
                   <a:srgbClr val="5C6E7A"/>
                 </a:solidFill>
@@ -7357,58 +8567,38 @@
                 <a:ea typeface="Arial" pitchFamily="34" charset="-122"/>
                 <a:cs typeface="Arial" pitchFamily="34" charset="-120"/>
               </a:rPr>
-              <a:t>Self-funded working prototype — 44-container fleet, memory, receipts, Society Protocol.</a:t>
-            </a:r>
-            <a:endParaRPr lang="en-US" sz="1350" dirty="0"/>
-          </a:p>
-        </p:txBody>
-      </p:sp>
-      <p:sp>
-        <p:nvSpPr>
-          <p:cNvPr id="8" name="Shape 6"/>
-          <p:cNvSpPr/>
-          <p:nvPr/>
-        </p:nvSpPr>
-        <p:spPr>
-          <a:xfrm>
-            <a:off x="3657600" y="2944368"/>
-            <a:ext cx="237744" cy="237744"/>
-          </a:xfrm>
-          <a:prstGeom prst="ellipse">
-            <a:avLst/>
-          </a:prstGeom>
-          <a:solidFill>
-            <a:srgbClr val="0B5D66"/>
-          </a:solidFill>
-          <a:ln/>
-        </p:spPr>
-      </p:sp>
-      <p:sp>
-        <p:nvSpPr>
-          <p:cNvPr id="9" name="Text 7"/>
-          <p:cNvSpPr/>
-          <p:nvPr/>
-        </p:nvSpPr>
-        <p:spPr>
-          <a:xfrm>
-            <a:off x="3703320" y="2468880"/>
-            <a:ext cx="2377440" cy="320040"/>
-          </a:xfrm>
-          <a:prstGeom prst="rect">
-            <a:avLst/>
-          </a:prstGeom>
-          <a:noFill/>
-          <a:ln/>
-        </p:spPr>
-        <p:txBody>
-          <a:bodyPr wrap="square" lIns="0" tIns="0" rIns="0" bIns="0" rtlCol="0" anchor="ctr"/>
-          <a:lstStyle/>
-          <a:p>
-            <a:pPr indent="0" marL="0">
-              <a:buNone/>
-            </a:pPr>
-            <a:r>
-              <a:rPr lang="en-US" sz="1500" b="1" spc="100" kern="0" dirty="0">
+              <a:t>Cloud memory &amp; traces — managed Qdrant + ClickHouse, zero-loss migration.</a:t>
+            </a:r>
+            <a:endParaRPr lang="en-US" sz="1200" dirty="0"/>
+          </a:p>
+        </p:txBody>
+      </p:sp>
+      <p:sp>
+        <p:nvSpPr>
+          <p:cNvPr id="20" name="Text 18"/>
+          <p:cNvSpPr/>
+          <p:nvPr/>
+        </p:nvSpPr>
+        <p:spPr>
+          <a:xfrm>
+            <a:off x="7223760" y="2990088"/>
+            <a:ext cx="548640" cy="365760"/>
+          </a:xfrm>
+          <a:prstGeom prst="rect">
+            <a:avLst/>
+          </a:prstGeom>
+          <a:noFill/>
+          <a:ln/>
+        </p:spPr>
+        <p:txBody>
+          <a:bodyPr wrap="square" lIns="0" tIns="0" rIns="0" bIns="0" rtlCol="0" anchor="ctr"/>
+          <a:lstStyle/>
+          <a:p>
+            <a:pPr indent="0" marL="0">
+              <a:buNone/>
+            </a:pPr>
+            <a:r>
+              <a:rPr lang="en-US" sz="1500" b="1" dirty="0">
                 <a:solidFill>
                   <a:srgbClr val="083F45"/>
                 </a:solidFill>
@@ -7416,7 +8606,7 @@
                 <a:ea typeface="Arial" pitchFamily="34" charset="-122"/>
                 <a:cs typeface="Arial" pitchFamily="34" charset="-120"/>
               </a:rPr>
-              <a:t>+3 MO</a:t>
+              <a:t>M2</a:t>
             </a:r>
             <a:endParaRPr lang="en-US" sz="1500" dirty="0"/>
           </a:p>
@@ -7424,33 +8614,30 @@
       </p:sp>
       <p:sp>
         <p:nvSpPr>
-          <p:cNvPr id="10" name="Text 8"/>
-          <p:cNvSpPr/>
-          <p:nvPr/>
-        </p:nvSpPr>
-        <p:spPr>
-          <a:xfrm>
-            <a:off x="3703320" y="3383280"/>
-            <a:ext cx="2514600" cy="1463040"/>
-          </a:xfrm>
-          <a:prstGeom prst="rect">
-            <a:avLst/>
-          </a:prstGeom>
-          <a:noFill/>
-          <a:ln/>
-        </p:spPr>
-        <p:txBody>
-          <a:bodyPr wrap="square" lIns="0" tIns="0" rIns="0" bIns="0" rtlCol="0" anchor="ctr"/>
-          <a:lstStyle/>
-          <a:p>
-            <a:pPr indent="0" marL="0">
-              <a:lnSpc>
-                <a:spcPts val="1800"/>
-              </a:lnSpc>
-              <a:buNone/>
-            </a:pPr>
-            <a:r>
-              <a:rPr lang="en-US" sz="1350" dirty="0">
+          <p:cNvPr id="21" name="Text 19"/>
+          <p:cNvSpPr/>
+          <p:nvPr/>
+        </p:nvSpPr>
+        <p:spPr>
+          <a:xfrm>
+            <a:off x="7818120" y="2990088"/>
+            <a:ext cx="3657600" cy="658368"/>
+          </a:xfrm>
+          <a:prstGeom prst="rect">
+            <a:avLst/>
+          </a:prstGeom>
+          <a:noFill/>
+          <a:ln/>
+        </p:spPr>
+        <p:txBody>
+          <a:bodyPr wrap="square" lIns="0" tIns="0" rIns="0" bIns="0" rtlCol="0" anchor="ctr"/>
+          <a:lstStyle/>
+          <a:p>
+            <a:pPr indent="0" marL="0">
+              <a:buNone/>
+            </a:pPr>
+            <a:r>
+              <a:rPr lang="en-US" sz="1200" dirty="0">
                 <a:solidFill>
                   <a:srgbClr val="5C6E7A"/>
                 </a:solidFill>
@@ -7458,58 +8645,38 @@
                 <a:ea typeface="Arial" pitchFamily="34" charset="-122"/>
                 <a:cs typeface="Arial" pitchFamily="34" charset="-120"/>
               </a:rPr>
-              <a:t>Mentor as a Service pilot — public API, first external students, paid sessions.</a:t>
-            </a:r>
-            <a:endParaRPr lang="en-US" sz="1350" dirty="0"/>
-          </a:p>
-        </p:txBody>
-      </p:sp>
-      <p:sp>
-        <p:nvSpPr>
-          <p:cNvPr id="11" name="Shape 9"/>
-          <p:cNvSpPr/>
-          <p:nvPr/>
-        </p:nvSpPr>
-        <p:spPr>
-          <a:xfrm>
-            <a:off x="6446520" y="2944368"/>
-            <a:ext cx="237744" cy="237744"/>
-          </a:xfrm>
-          <a:prstGeom prst="ellipse">
-            <a:avLst/>
-          </a:prstGeom>
-          <a:solidFill>
-            <a:srgbClr val="0B5D66"/>
-          </a:solidFill>
-          <a:ln/>
-        </p:spPr>
-      </p:sp>
-      <p:sp>
-        <p:nvSpPr>
-          <p:cNvPr id="12" name="Text 10"/>
-          <p:cNvSpPr/>
-          <p:nvPr/>
-        </p:nvSpPr>
-        <p:spPr>
-          <a:xfrm>
-            <a:off x="6492240" y="2468880"/>
-            <a:ext cx="2377440" cy="320040"/>
-          </a:xfrm>
-          <a:prstGeom prst="rect">
-            <a:avLst/>
-          </a:prstGeom>
-          <a:noFill/>
-          <a:ln/>
-        </p:spPr>
-        <p:txBody>
-          <a:bodyPr wrap="square" lIns="0" tIns="0" rIns="0" bIns="0" rtlCol="0" anchor="ctr"/>
-          <a:lstStyle/>
-          <a:p>
-            <a:pPr indent="0" marL="0">
-              <a:buNone/>
-            </a:pPr>
-            <a:r>
-              <a:rPr lang="en-US" sz="1500" b="1" spc="100" kern="0" dirty="0">
+              <a:t>GPU voice mentor pilot — 10 students, measured cloud latency.</a:t>
+            </a:r>
+            <a:endParaRPr lang="en-US" sz="1200" dirty="0"/>
+          </a:p>
+        </p:txBody>
+      </p:sp>
+      <p:sp>
+        <p:nvSpPr>
+          <p:cNvPr id="22" name="Text 20"/>
+          <p:cNvSpPr/>
+          <p:nvPr/>
+        </p:nvSpPr>
+        <p:spPr>
+          <a:xfrm>
+            <a:off x="7223760" y="3739896"/>
+            <a:ext cx="548640" cy="365760"/>
+          </a:xfrm>
+          <a:prstGeom prst="rect">
+            <a:avLst/>
+          </a:prstGeom>
+          <a:noFill/>
+          <a:ln/>
+        </p:spPr>
+        <p:txBody>
+          <a:bodyPr wrap="square" lIns="0" tIns="0" rIns="0" bIns="0" rtlCol="0" anchor="ctr"/>
+          <a:lstStyle/>
+          <a:p>
+            <a:pPr indent="0" marL="0">
+              <a:buNone/>
+            </a:pPr>
+            <a:r>
+              <a:rPr lang="en-US" sz="1500" b="1" dirty="0">
                 <a:solidFill>
                   <a:srgbClr val="083F45"/>
                 </a:solidFill>
@@ -7517,7 +8684,7 @@
                 <a:ea typeface="Arial" pitchFamily="34" charset="-122"/>
                 <a:cs typeface="Arial" pitchFamily="34" charset="-120"/>
               </a:rPr>
-              <a:t>+6 MO</a:t>
+              <a:t>M3</a:t>
             </a:r>
             <a:endParaRPr lang="en-US" sz="1500" dirty="0"/>
           </a:p>
@@ -7525,33 +8692,30 @@
       </p:sp>
       <p:sp>
         <p:nvSpPr>
-          <p:cNvPr id="13" name="Text 11"/>
-          <p:cNvSpPr/>
-          <p:nvPr/>
-        </p:nvSpPr>
-        <p:spPr>
-          <a:xfrm>
-            <a:off x="6492240" y="3383280"/>
-            <a:ext cx="2514600" cy="1463040"/>
-          </a:xfrm>
-          <a:prstGeom prst="rect">
-            <a:avLst/>
-          </a:prstGeom>
-          <a:noFill/>
-          <a:ln/>
-        </p:spPr>
-        <p:txBody>
-          <a:bodyPr wrap="square" lIns="0" tIns="0" rIns="0" bIns="0" rtlCol="0" anchor="ctr"/>
-          <a:lstStyle/>
-          <a:p>
-            <a:pPr indent="0" marL="0">
-              <a:lnSpc>
-                <a:spcPts val="1800"/>
-              </a:lnSpc>
-              <a:buNone/>
-            </a:pPr>
-            <a:r>
-              <a:rPr lang="en-US" sz="1350" dirty="0">
+          <p:cNvPr id="23" name="Text 21"/>
+          <p:cNvSpPr/>
+          <p:nvPr/>
+        </p:nvSpPr>
+        <p:spPr>
+          <a:xfrm>
+            <a:off x="7818120" y="3739896"/>
+            <a:ext cx="3657600" cy="658368"/>
+          </a:xfrm>
+          <a:prstGeom prst="rect">
+            <a:avLst/>
+          </a:prstGeom>
+          <a:noFill/>
+          <a:ln/>
+        </p:spPr>
+        <p:txBody>
+          <a:bodyPr wrap="square" lIns="0" tIns="0" rIns="0" bIns="0" rtlCol="0" anchor="ctr"/>
+          <a:lstStyle/>
+          <a:p>
+            <a:pPr indent="0" marL="0">
+              <a:buNone/>
+            </a:pPr>
+            <a:r>
+              <a:rPr lang="en-US" sz="1200" dirty="0">
                 <a:solidFill>
                   <a:srgbClr val="5C6E7A"/>
                 </a:solidFill>
@@ -7559,100 +8723,139 @@
                 <a:ea typeface="Arial" pitchFamily="34" charset="-122"/>
                 <a:cs typeface="Arial" pitchFamily="34" charset="-120"/>
               </a:rPr>
-              <a:t>Cloud fleet — managed memory &amp; traces, GPU voice mentors, 24/7 uptime.</a:t>
-            </a:r>
-            <a:endParaRPr lang="en-US" sz="1350" dirty="0"/>
-          </a:p>
-        </p:txBody>
-      </p:sp>
-      <p:sp>
-        <p:nvSpPr>
-          <p:cNvPr id="14" name="Shape 12"/>
-          <p:cNvSpPr/>
-          <p:nvPr/>
-        </p:nvSpPr>
-        <p:spPr>
-          <a:xfrm>
-            <a:off x="9235440" y="2944368"/>
-            <a:ext cx="237744" cy="237744"/>
-          </a:xfrm>
-          <a:prstGeom prst="ellipse">
-            <a:avLst/>
-          </a:prstGeom>
-          <a:solidFill>
-            <a:srgbClr val="0B5D66"/>
-          </a:solidFill>
-          <a:ln/>
-        </p:spPr>
-      </p:sp>
-      <p:sp>
-        <p:nvSpPr>
-          <p:cNvPr id="15" name="Text 13"/>
-          <p:cNvSpPr/>
-          <p:nvPr/>
-        </p:nvSpPr>
-        <p:spPr>
-          <a:xfrm>
-            <a:off x="9281160" y="2468880"/>
-            <a:ext cx="2377440" cy="320040"/>
-          </a:xfrm>
-          <a:prstGeom prst="rect">
-            <a:avLst/>
-          </a:prstGeom>
-          <a:noFill/>
-          <a:ln/>
-        </p:spPr>
-        <p:txBody>
-          <a:bodyPr wrap="square" lIns="0" tIns="0" rIns="0" bIns="0" rtlCol="0" anchor="ctr"/>
-          <a:lstStyle/>
-          <a:p>
-            <a:pPr indent="0" marL="0">
-              <a:buNone/>
-            </a:pPr>
-            <a:r>
-              <a:rPr lang="en-US" sz="1500" b="1" spc="100" kern="0" dirty="0">
-                <a:solidFill>
-                  <a:srgbClr val="083F45"/>
-                </a:solidFill>
-                <a:latin typeface="Arial" pitchFamily="34" charset="0"/>
-                <a:ea typeface="Arial" pitchFamily="34" charset="-122"/>
-                <a:cs typeface="Arial" pitchFamily="34" charset="-120"/>
-              </a:rPr>
-              <a:t>+12 MO</a:t>
-            </a:r>
-            <a:endParaRPr lang="en-US" sz="1500" dirty="0"/>
-          </a:p>
-        </p:txBody>
-      </p:sp>
-      <p:sp>
-        <p:nvSpPr>
-          <p:cNvPr id="16" name="Text 14"/>
-          <p:cNvSpPr/>
-          <p:nvPr/>
-        </p:nvSpPr>
-        <p:spPr>
-          <a:xfrm>
-            <a:off x="9281160" y="3383280"/>
-            <a:ext cx="2514600" cy="1463040"/>
-          </a:xfrm>
-          <a:prstGeom prst="rect">
-            <a:avLst/>
-          </a:prstGeom>
-          <a:noFill/>
-          <a:ln/>
-        </p:spPr>
-        <p:txBody>
-          <a:bodyPr wrap="square" lIns="0" tIns="0" rIns="0" bIns="0" rtlCol="0" anchor="ctr"/>
-          <a:lstStyle/>
-          <a:p>
-            <a:pPr indent="0" marL="0">
-              <a:lnSpc>
-                <a:spcPts val="1800"/>
-              </a:lnSpc>
-              <a:buNone/>
-            </a:pPr>
-            <a:r>
-              <a:rPr lang="en-US" sz="1350" dirty="0">
+              <a:t>Public Mentor API beta — first external students onboarded.</a:t>
+            </a:r>
+            <a:endParaRPr lang="en-US" sz="1200" dirty="0"/>
+          </a:p>
+        </p:txBody>
+      </p:sp>
+      <p:sp>
+        <p:nvSpPr>
+          <p:cNvPr id="24" name="Shape 22"/>
+          <p:cNvSpPr/>
+          <p:nvPr/>
+        </p:nvSpPr>
+        <p:spPr>
+          <a:xfrm>
+            <a:off x="7223760" y="4526280"/>
+            <a:ext cx="4160520" cy="0"/>
+          </a:xfrm>
+          <a:prstGeom prst="line">
+            <a:avLst/>
+          </a:prstGeom>
+          <a:noFill/>
+          <a:ln w="12700">
+            <a:solidFill>
+              <a:srgbClr val="D5DEE2"/>
+            </a:solidFill>
+            <a:prstDash val="solid"/>
+          </a:ln>
+        </p:spPr>
+      </p:sp>
+      <p:sp>
+        <p:nvSpPr>
+          <p:cNvPr id="25" name="Text 23"/>
+          <p:cNvSpPr/>
+          <p:nvPr/>
+        </p:nvSpPr>
+        <p:spPr>
+          <a:xfrm>
+            <a:off x="7223760" y="4663440"/>
+            <a:ext cx="4206240" cy="274320"/>
+          </a:xfrm>
+          <a:prstGeom prst="rect">
+            <a:avLst/>
+          </a:prstGeom>
+          <a:noFill/>
+          <a:ln/>
+        </p:spPr>
+        <p:txBody>
+          <a:bodyPr wrap="square" lIns="0" tIns="0" rIns="0" bIns="0" rtlCol="0" anchor="ctr"/>
+          <a:lstStyle/>
+          <a:p>
+            <a:pPr indent="0" marL="0">
+              <a:buNone/>
+            </a:pPr>
+            <a:r>
+              <a:rPr lang="en-US" sz="1200" b="1" spc="200" kern="0" dirty="0">
+                <a:solidFill>
+                  <a:srgbClr val="D97706"/>
+                </a:solidFill>
+                <a:latin typeface="Arial" pitchFamily="34" charset="0"/>
+                <a:ea typeface="Arial" pitchFamily="34" charset="-122"/>
+                <a:cs typeface="Arial" pitchFamily="34" charset="-120"/>
+              </a:rPr>
+              <a:t>SUCCESS METRICS · TARGETS</a:t>
+            </a:r>
+            <a:endParaRPr lang="en-US" sz="1200" dirty="0"/>
+          </a:p>
+        </p:txBody>
+      </p:sp>
+      <p:sp>
+        <p:nvSpPr>
+          <p:cNvPr id="26" name="Text 24"/>
+          <p:cNvSpPr/>
+          <p:nvPr/>
+        </p:nvSpPr>
+        <p:spPr>
+          <a:xfrm>
+            <a:off x="7223760" y="4983480"/>
+            <a:ext cx="4160520" cy="731520"/>
+          </a:xfrm>
+          <a:prstGeom prst="rect">
+            <a:avLst/>
+          </a:prstGeom>
+          <a:noFill/>
+          <a:ln/>
+        </p:spPr>
+        <p:txBody>
+          <a:bodyPr wrap="square" lIns="0" tIns="0" rIns="0" bIns="0" rtlCol="0" anchor="ctr"/>
+          <a:lstStyle/>
+          <a:p>
+            <a:pPr indent="0" marL="0">
+              <a:buNone/>
+            </a:pPr>
+            <a:r>
+              <a:rPr lang="en-US" sz="1250" dirty="0">
+                <a:solidFill>
+                  <a:srgbClr val="17242C"/>
+                </a:solidFill>
+                <a:latin typeface="Arial" pitchFamily="34" charset="0"/>
+                <a:ea typeface="Arial" pitchFamily="34" charset="-122"/>
+                <a:cs typeface="Arial" pitchFamily="34" charset="-120"/>
+              </a:rPr>
+              <a:t>20 pilot students · first paid session · 99.5% uptime · recall latency p95 &lt; 300 ms</a:t>
+            </a:r>
+            <a:endParaRPr lang="en-US" sz="1250" dirty="0"/>
+          </a:p>
+        </p:txBody>
+      </p:sp>
+      <p:sp>
+        <p:nvSpPr>
+          <p:cNvPr id="27" name="Text 25"/>
+          <p:cNvSpPr/>
+          <p:nvPr/>
+        </p:nvSpPr>
+        <p:spPr>
+          <a:xfrm>
+            <a:off x="548640" y="6263640"/>
+            <a:ext cx="10972800" cy="274320"/>
+          </a:xfrm>
+          <a:prstGeom prst="rect">
+            <a:avLst/>
+          </a:prstGeom>
+          <a:noFill/>
+          <a:ln/>
+        </p:spPr>
+        <p:txBody>
+          <a:bodyPr wrap="square" lIns="0" tIns="0" rIns="0" bIns="0" rtlCol="0" anchor="ctr"/>
+          <a:lstStyle/>
+          <a:p>
+            <a:pPr indent="0" marL="0">
+              <a:buNone/>
+            </a:pPr>
+            <a:r>
+              <a:rPr lang="en-US" sz="1200" dirty="0">
                 <a:solidFill>
                   <a:srgbClr val="5C6E7A"/>
                 </a:solidFill>
@@ -7660,82 +8863,9 @@
                 <a:ea typeface="Arial" pitchFamily="34" charset="-122"/>
                 <a:cs typeface="Arial" pitchFamily="34" charset="-120"/>
               </a:rPr>
-              <a:t>Governed copilots beyond gaming — agents you can audit, as a category.</a:t>
-            </a:r>
-            <a:endParaRPr lang="en-US" sz="1350" dirty="0"/>
-          </a:p>
-        </p:txBody>
-      </p:sp>
-      <p:sp>
-        <p:nvSpPr>
-          <p:cNvPr id="17" name="Shape 15"/>
-          <p:cNvSpPr/>
-          <p:nvPr/>
-        </p:nvSpPr>
-        <p:spPr>
-          <a:xfrm>
-            <a:off x="0" y="5257800"/>
-            <a:ext cx="12188952" cy="914400"/>
-          </a:xfrm>
-          <a:prstGeom prst="rect">
-            <a:avLst/>
-          </a:prstGeom>
-          <a:solidFill>
-            <a:srgbClr val="E7F1F1"/>
-          </a:solidFill>
-          <a:ln/>
-        </p:spPr>
-      </p:sp>
-      <p:sp>
-        <p:nvSpPr>
-          <p:cNvPr id="18" name="Text 16"/>
-          <p:cNvSpPr/>
-          <p:nvPr/>
-        </p:nvSpPr>
-        <p:spPr>
-          <a:xfrm>
-            <a:off x="822960" y="5257800"/>
-            <a:ext cx="10607040" cy="914400"/>
-          </a:xfrm>
-          <a:prstGeom prst="rect">
-            <a:avLst/>
-          </a:prstGeom>
-          <a:noFill/>
-          <a:ln/>
-        </p:spPr>
-        <p:txBody>
-          <a:bodyPr wrap="square" lIns="0" tIns="0" rIns="0" bIns="0" rtlCol="0" anchor="ctr"/>
-          <a:lstStyle/>
-          <a:p>
-            <a:pPr indent="0" marL="0">
-              <a:buNone/>
-            </a:pPr>
-            <a:r>
-              <a:rPr lang="en-US" sz="1400" b="1" dirty="0">
-                <a:solidFill>
-                  <a:srgbClr val="083F45"/>
-                </a:solidFill>
-                <a:latin typeface="Arial" pitchFamily="34" charset="0"/>
-                <a:ea typeface="Arial" pitchFamily="34" charset="-122"/>
-                <a:cs typeface="Arial" pitchFamily="34" charset="-120"/>
-              </a:rPr>
-              <a:t>Honest baseline: </a:t>
-            </a:r>
-            <a:pPr indent="0" marL="0">
-              <a:buNone/>
-            </a:pPr>
-            <a:r>
-              <a:rPr lang="en-US" sz="1400" dirty="0">
-                <a:solidFill>
-                  <a:srgbClr val="17242C"/>
-                </a:solidFill>
-                <a:latin typeface="Arial" pitchFamily="34" charset="0"/>
-                <a:ea typeface="Arial" pitchFamily="34" charset="-122"/>
-                <a:cs typeface="Arial" pitchFamily="34" charset="-120"/>
-              </a:rPr>
-              <a:t>no users and no revenue yet. This deck sells a working prototype with live infrastructure — the roadmap is a plan, not a projection.</a:t>
-            </a:r>
-            <a:endParaRPr lang="en-US" sz="1400" dirty="0"/>
+              <a:t>Beachhead: mentors for students and small teams. Credits go to infrastructure, not headcount.</a:t>
+            </a:r>
+            <a:endParaRPr lang="en-US" sz="1200" dirty="0"/>
           </a:p>
         </p:txBody>
       </p:sp>
@@ -7753,7 +8883,7 @@
     <p:bg>
       <p:bgPr>
         <a:solidFill>
-          <a:srgbClr val="0D1B24"/>
+          <a:srgbClr val="FFFFFF"/>
         </a:solidFill>
       </p:bgPr>
     </p:bg>
@@ -7773,22 +8903,100 @@
       </p:grpSpPr>
       <p:sp>
         <p:nvSpPr>
-          <p:cNvPr id="2" name="Shape 0"/>
-          <p:cNvSpPr/>
-          <p:nvPr/>
-        </p:nvSpPr>
-        <p:spPr>
-          <a:xfrm>
-            <a:off x="10332720" y="5120640"/>
-            <a:ext cx="1083323" cy="503049"/>
+          <p:cNvPr id="2" name="Text 0"/>
+          <p:cNvSpPr/>
+          <p:nvPr/>
+        </p:nvSpPr>
+        <p:spPr>
+          <a:xfrm>
+            <a:off x="548640" y="384048"/>
+            <a:ext cx="7315200" cy="274320"/>
+          </a:xfrm>
+          <a:prstGeom prst="rect">
+            <a:avLst/>
+          </a:prstGeom>
+          <a:noFill/>
+          <a:ln/>
+        </p:spPr>
+        <p:txBody>
+          <a:bodyPr wrap="square" lIns="0" tIns="0" rIns="0" bIns="0" rtlCol="0" anchor="ctr"/>
+          <a:lstStyle/>
+          <a:p>
+            <a:pPr indent="0" marL="0">
+              <a:buNone/>
+            </a:pPr>
+            <a:r>
+              <a:rPr lang="en-US" sz="1200" b="1" spc="300" kern="0" dirty="0">
+                <a:solidFill>
+                  <a:srgbClr val="D97706"/>
+                </a:solidFill>
+                <a:latin typeface="Arial" pitchFamily="34" charset="0"/>
+                <a:ea typeface="Arial" pitchFamily="34" charset="-122"/>
+                <a:cs typeface="Arial" pitchFamily="34" charset="-120"/>
+              </a:rPr>
+              <a:t>ROADMAP</a:t>
+            </a:r>
+            <a:endParaRPr lang="en-US" sz="1200" dirty="0"/>
+          </a:p>
+        </p:txBody>
+      </p:sp>
+      <p:sp>
+        <p:nvSpPr>
+          <p:cNvPr id="3" name="Text 1"/>
+          <p:cNvSpPr/>
+          <p:nvPr/>
+        </p:nvSpPr>
+        <p:spPr>
+          <a:xfrm>
+            <a:off x="548640" y="658368"/>
+            <a:ext cx="10241280" cy="777240"/>
+          </a:xfrm>
+          <a:prstGeom prst="rect">
+            <a:avLst/>
+          </a:prstGeom>
+          <a:noFill/>
+          <a:ln/>
+        </p:spPr>
+        <p:txBody>
+          <a:bodyPr wrap="square" lIns="0" tIns="0" rIns="0" bIns="0" rtlCol="0" anchor="ctr"/>
+          <a:lstStyle/>
+          <a:p>
+            <a:pPr indent="0" marL="0">
+              <a:buNone/>
+            </a:pPr>
+            <a:r>
+              <a:rPr lang="en-US" sz="3000" b="1" dirty="0">
+                <a:solidFill>
+                  <a:srgbClr val="0D1B24"/>
+                </a:solidFill>
+                <a:latin typeface="Arial" pitchFamily="34" charset="0"/>
+                <a:ea typeface="Arial" pitchFamily="34" charset="-122"/>
+                <a:cs typeface="Arial" pitchFamily="34" charset="-120"/>
+              </a:rPr>
+              <a:t>From working prototype to hosted runtime.</a:t>
+            </a:r>
+            <a:endParaRPr lang="en-US" sz="3000" dirty="0"/>
+          </a:p>
+        </p:txBody>
+      </p:sp>
+      <p:sp>
+        <p:nvSpPr>
+          <p:cNvPr id="4" name="Shape 2"/>
+          <p:cNvSpPr/>
+          <p:nvPr/>
+        </p:nvSpPr>
+        <p:spPr>
+          <a:xfrm>
+            <a:off x="914400" y="3063240"/>
+            <a:ext cx="10332720" cy="0"/>
           </a:xfrm>
           <a:prstGeom prst="line">
             <a:avLst/>
           </a:prstGeom>
           <a:noFill/>
-          <a:ln w="12700">
+          <a:ln w="25400">
             <a:solidFill>
-              <a:srgbClr val="27414E"/>
+              <a:srgbClr val="C9DADB"/>
             </a:solidFill>
             <a:prstDash val="solid"/>
           </a:ln>
@@ -7796,169 +9004,14 @@
       </p:sp>
       <p:sp>
         <p:nvSpPr>
-          <p:cNvPr id="3" name="Shape 1"/>
-          <p:cNvSpPr/>
-          <p:nvPr/>
-        </p:nvSpPr>
-        <p:spPr>
-          <a:xfrm>
-            <a:off x="10332720" y="5120640"/>
-            <a:ext cx="29129" cy="1048982"/>
-          </a:xfrm>
-          <a:prstGeom prst="line">
-            <a:avLst/>
-          </a:prstGeom>
-          <a:noFill/>
-          <a:ln w="12700">
-            <a:solidFill>
-              <a:srgbClr val="27414E"/>
-            </a:solidFill>
-            <a:prstDash val="solid"/>
-          </a:ln>
-        </p:spPr>
-      </p:sp>
-      <p:sp>
-        <p:nvSpPr>
-          <p:cNvPr id="4" name="Shape 2"/>
-          <p:cNvSpPr/>
-          <p:nvPr/>
-        </p:nvSpPr>
-        <p:spPr>
-          <a:xfrm>
-            <a:off x="10332720" y="5120640"/>
-            <a:ext cx="-1054194" cy="545933"/>
-          </a:xfrm>
-          <a:prstGeom prst="line">
-            <a:avLst/>
-          </a:prstGeom>
-          <a:noFill/>
-          <a:ln w="12700">
-            <a:solidFill>
-              <a:srgbClr val="27414E"/>
-            </a:solidFill>
-            <a:prstDash val="solid"/>
-          </a:ln>
-        </p:spPr>
-      </p:sp>
-      <p:sp>
-        <p:nvSpPr>
           <p:cNvPr id="5" name="Shape 3"/>
           <p:cNvSpPr/>
           <p:nvPr/>
         </p:nvSpPr>
         <p:spPr>
           <a:xfrm>
-            <a:off x="10332720" y="5120640"/>
-            <a:ext cx="-1083323" cy="-503049"/>
-          </a:xfrm>
-          <a:prstGeom prst="line">
-            <a:avLst/>
-          </a:prstGeom>
-          <a:noFill/>
-          <a:ln w="12700">
-            <a:solidFill>
-              <a:srgbClr val="27414E"/>
-            </a:solidFill>
-            <a:prstDash val="solid"/>
-          </a:ln>
-        </p:spPr>
-      </p:sp>
-      <p:sp>
-        <p:nvSpPr>
-          <p:cNvPr id="6" name="Shape 4"/>
-          <p:cNvSpPr/>
-          <p:nvPr/>
-        </p:nvSpPr>
-        <p:spPr>
-          <a:xfrm>
-            <a:off x="10332720" y="5120640"/>
-            <a:ext cx="-29129" cy="-1048982"/>
-          </a:xfrm>
-          <a:prstGeom prst="line">
-            <a:avLst/>
-          </a:prstGeom>
-          <a:noFill/>
-          <a:ln w="12700">
-            <a:solidFill>
-              <a:srgbClr val="27414E"/>
-            </a:solidFill>
-            <a:prstDash val="solid"/>
-          </a:ln>
-        </p:spPr>
-      </p:sp>
-      <p:sp>
-        <p:nvSpPr>
-          <p:cNvPr id="7" name="Shape 5"/>
-          <p:cNvSpPr/>
-          <p:nvPr/>
-        </p:nvSpPr>
-        <p:spPr>
-          <a:xfrm>
-            <a:off x="10332720" y="5120640"/>
-            <a:ext cx="1054194" cy="-545933"/>
-          </a:xfrm>
-          <a:prstGeom prst="line">
-            <a:avLst/>
-          </a:prstGeom>
-          <a:noFill/>
-          <a:ln w="12700">
-            <a:solidFill>
-              <a:srgbClr val="27414E"/>
-            </a:solidFill>
-            <a:prstDash val="solid"/>
-          </a:ln>
-        </p:spPr>
-      </p:sp>
-      <p:sp>
-        <p:nvSpPr>
-          <p:cNvPr id="8" name="Shape 6"/>
-          <p:cNvSpPr/>
-          <p:nvPr/>
-        </p:nvSpPr>
-        <p:spPr>
-          <a:xfrm>
-            <a:off x="11347463" y="5555109"/>
-            <a:ext cx="137160" cy="137160"/>
-          </a:xfrm>
-          <a:prstGeom prst="ellipse">
-            <a:avLst/>
-          </a:prstGeom>
-          <a:solidFill>
-            <a:srgbClr val="7FC4C9"/>
-          </a:solidFill>
-          <a:ln/>
-        </p:spPr>
-      </p:sp>
-      <p:sp>
-        <p:nvSpPr>
-          <p:cNvPr id="9" name="Shape 7"/>
-          <p:cNvSpPr/>
-          <p:nvPr/>
-        </p:nvSpPr>
-        <p:spPr>
-          <a:xfrm>
-            <a:off x="10311557" y="6119330"/>
-            <a:ext cx="100584" cy="100584"/>
-          </a:xfrm>
-          <a:prstGeom prst="ellipse">
-            <a:avLst/>
-          </a:prstGeom>
-          <a:solidFill>
-            <a:srgbClr val="7FC4C9"/>
-          </a:solidFill>
-          <a:ln/>
-        </p:spPr>
-      </p:sp>
-      <p:sp>
-        <p:nvSpPr>
-          <p:cNvPr id="10" name="Shape 8"/>
-          <p:cNvSpPr/>
-          <p:nvPr/>
-        </p:nvSpPr>
-        <p:spPr>
-          <a:xfrm>
-            <a:off x="9209946" y="5597993"/>
-            <a:ext cx="137160" cy="137160"/>
+            <a:off x="868680" y="2944368"/>
+            <a:ext cx="237744" cy="237744"/>
           </a:xfrm>
           <a:prstGeom prst="ellipse">
             <a:avLst/>
@@ -7971,446 +9024,458 @@
       </p:sp>
       <p:sp>
         <p:nvSpPr>
+          <p:cNvPr id="6" name="Text 4"/>
+          <p:cNvSpPr/>
+          <p:nvPr/>
+        </p:nvSpPr>
+        <p:spPr>
+          <a:xfrm>
+            <a:off x="914400" y="2468880"/>
+            <a:ext cx="2377440" cy="320040"/>
+          </a:xfrm>
+          <a:prstGeom prst="rect">
+            <a:avLst/>
+          </a:prstGeom>
+          <a:noFill/>
+          <a:ln/>
+        </p:spPr>
+        <p:txBody>
+          <a:bodyPr wrap="square" lIns="0" tIns="0" rIns="0" bIns="0" rtlCol="0" anchor="ctr"/>
+          <a:lstStyle/>
+          <a:p>
+            <a:pPr indent="0" marL="0">
+              <a:buNone/>
+            </a:pPr>
+            <a:r>
+              <a:rPr lang="en-US" sz="1500" b="1" spc="100" kern="0" dirty="0">
+                <a:solidFill>
+                  <a:srgbClr val="D97706"/>
+                </a:solidFill>
+                <a:latin typeface="Arial" pitchFamily="34" charset="0"/>
+                <a:ea typeface="Arial" pitchFamily="34" charset="-122"/>
+                <a:cs typeface="Arial" pitchFamily="34" charset="-120"/>
+              </a:rPr>
+              <a:t>NOW</a:t>
+            </a:r>
+            <a:endParaRPr lang="en-US" sz="1500" dirty="0"/>
+          </a:p>
+        </p:txBody>
+      </p:sp>
+      <p:sp>
+        <p:nvSpPr>
+          <p:cNvPr id="7" name="Text 5"/>
+          <p:cNvSpPr/>
+          <p:nvPr/>
+        </p:nvSpPr>
+        <p:spPr>
+          <a:xfrm>
+            <a:off x="914400" y="3383280"/>
+            <a:ext cx="2514600" cy="1463040"/>
+          </a:xfrm>
+          <a:prstGeom prst="rect">
+            <a:avLst/>
+          </a:prstGeom>
+          <a:noFill/>
+          <a:ln/>
+        </p:spPr>
+        <p:txBody>
+          <a:bodyPr wrap="square" lIns="0" tIns="0" rIns="0" bIns="0" rtlCol="0" anchor="ctr"/>
+          <a:lstStyle/>
+          <a:p>
+            <a:pPr indent="0" marL="0">
+              <a:lnSpc>
+                <a:spcPts val="1800"/>
+              </a:lnSpc>
+              <a:buNone/>
+            </a:pPr>
+            <a:r>
+              <a:rPr lang="en-US" sz="1350" dirty="0">
+                <a:solidFill>
+                  <a:srgbClr val="5C6E7A"/>
+                </a:solidFill>
+                <a:latin typeface="Arial" pitchFamily="34" charset="0"/>
+                <a:ea typeface="Arial" pitchFamily="34" charset="-122"/>
+                <a:cs typeface="Arial" pitchFamily="34" charset="-120"/>
+              </a:rPr>
+              <a:t>Self-funded working prototype — 44-container fleet, memory, receipts, Society Protocol.</a:t>
+            </a:r>
+            <a:endParaRPr lang="en-US" sz="1350" dirty="0"/>
+          </a:p>
+        </p:txBody>
+      </p:sp>
+      <p:sp>
+        <p:nvSpPr>
+          <p:cNvPr id="8" name="Shape 6"/>
+          <p:cNvSpPr/>
+          <p:nvPr/>
+        </p:nvSpPr>
+        <p:spPr>
+          <a:xfrm>
+            <a:off x="3657600" y="2944368"/>
+            <a:ext cx="237744" cy="237744"/>
+          </a:xfrm>
+          <a:prstGeom prst="ellipse">
+            <a:avLst/>
+          </a:prstGeom>
+          <a:solidFill>
+            <a:srgbClr val="0B5D66"/>
+          </a:solidFill>
+          <a:ln/>
+        </p:spPr>
+      </p:sp>
+      <p:sp>
+        <p:nvSpPr>
+          <p:cNvPr id="9" name="Text 7"/>
+          <p:cNvSpPr/>
+          <p:nvPr/>
+        </p:nvSpPr>
+        <p:spPr>
+          <a:xfrm>
+            <a:off x="3703320" y="2468880"/>
+            <a:ext cx="2377440" cy="320040"/>
+          </a:xfrm>
+          <a:prstGeom prst="rect">
+            <a:avLst/>
+          </a:prstGeom>
+          <a:noFill/>
+          <a:ln/>
+        </p:spPr>
+        <p:txBody>
+          <a:bodyPr wrap="square" lIns="0" tIns="0" rIns="0" bIns="0" rtlCol="0" anchor="ctr"/>
+          <a:lstStyle/>
+          <a:p>
+            <a:pPr indent="0" marL="0">
+              <a:buNone/>
+            </a:pPr>
+            <a:r>
+              <a:rPr lang="en-US" sz="1500" b="1" spc="100" kern="0" dirty="0">
+                <a:solidFill>
+                  <a:srgbClr val="083F45"/>
+                </a:solidFill>
+                <a:latin typeface="Arial" pitchFamily="34" charset="0"/>
+                <a:ea typeface="Arial" pitchFamily="34" charset="-122"/>
+                <a:cs typeface="Arial" pitchFamily="34" charset="-120"/>
+              </a:rPr>
+              <a:t>+3 MO</a:t>
+            </a:r>
+            <a:endParaRPr lang="en-US" sz="1500" dirty="0"/>
+          </a:p>
+        </p:txBody>
+      </p:sp>
+      <p:sp>
+        <p:nvSpPr>
+          <p:cNvPr id="10" name="Text 8"/>
+          <p:cNvSpPr/>
+          <p:nvPr/>
+        </p:nvSpPr>
+        <p:spPr>
+          <a:xfrm>
+            <a:off x="3703320" y="3383280"/>
+            <a:ext cx="2514600" cy="1463040"/>
+          </a:xfrm>
+          <a:prstGeom prst="rect">
+            <a:avLst/>
+          </a:prstGeom>
+          <a:noFill/>
+          <a:ln/>
+        </p:spPr>
+        <p:txBody>
+          <a:bodyPr wrap="square" lIns="0" tIns="0" rIns="0" bIns="0" rtlCol="0" anchor="ctr"/>
+          <a:lstStyle/>
+          <a:p>
+            <a:pPr indent="0" marL="0">
+              <a:lnSpc>
+                <a:spcPts val="1800"/>
+              </a:lnSpc>
+              <a:buNone/>
+            </a:pPr>
+            <a:r>
+              <a:rPr lang="en-US" sz="1350" dirty="0">
+                <a:solidFill>
+                  <a:srgbClr val="5C6E7A"/>
+                </a:solidFill>
+                <a:latin typeface="Arial" pitchFamily="34" charset="0"/>
+                <a:ea typeface="Arial" pitchFamily="34" charset="-122"/>
+                <a:cs typeface="Arial" pitchFamily="34" charset="-120"/>
+              </a:rPr>
+              <a:t>Mentor as a Service pilot — public API, first external students, paid sessions.</a:t>
+            </a:r>
+            <a:endParaRPr lang="en-US" sz="1350" dirty="0"/>
+          </a:p>
+        </p:txBody>
+      </p:sp>
+      <p:sp>
+        <p:nvSpPr>
           <p:cNvPr id="11" name="Shape 9"/>
           <p:cNvSpPr/>
           <p:nvPr/>
         </p:nvSpPr>
         <p:spPr>
           <a:xfrm>
-            <a:off x="9199105" y="4567299"/>
-            <a:ext cx="100584" cy="100584"/>
+            <a:off x="6446520" y="2944368"/>
+            <a:ext cx="237744" cy="237744"/>
           </a:xfrm>
           <a:prstGeom prst="ellipse">
             <a:avLst/>
           </a:prstGeom>
           <a:solidFill>
-            <a:srgbClr val="7FC4C9"/>
+            <a:srgbClr val="0B5D66"/>
           </a:solidFill>
           <a:ln/>
         </p:spPr>
       </p:sp>
       <p:sp>
         <p:nvSpPr>
-          <p:cNvPr id="12" name="Shape 10"/>
-          <p:cNvSpPr/>
-          <p:nvPr/>
-        </p:nvSpPr>
-        <p:spPr>
-          <a:xfrm>
-            <a:off x="10235011" y="4003078"/>
-            <a:ext cx="137160" cy="137160"/>
+          <p:cNvPr id="12" name="Text 10"/>
+          <p:cNvSpPr/>
+          <p:nvPr/>
+        </p:nvSpPr>
+        <p:spPr>
+          <a:xfrm>
+            <a:off x="6492240" y="2468880"/>
+            <a:ext cx="2377440" cy="320040"/>
+          </a:xfrm>
+          <a:prstGeom prst="rect">
+            <a:avLst/>
+          </a:prstGeom>
+          <a:noFill/>
+          <a:ln/>
+        </p:spPr>
+        <p:txBody>
+          <a:bodyPr wrap="square" lIns="0" tIns="0" rIns="0" bIns="0" rtlCol="0" anchor="ctr"/>
+          <a:lstStyle/>
+          <a:p>
+            <a:pPr indent="0" marL="0">
+              <a:buNone/>
+            </a:pPr>
+            <a:r>
+              <a:rPr lang="en-US" sz="1500" b="1" spc="100" kern="0" dirty="0">
+                <a:solidFill>
+                  <a:srgbClr val="083F45"/>
+                </a:solidFill>
+                <a:latin typeface="Arial" pitchFamily="34" charset="0"/>
+                <a:ea typeface="Arial" pitchFamily="34" charset="-122"/>
+                <a:cs typeface="Arial" pitchFamily="34" charset="-120"/>
+              </a:rPr>
+              <a:t>+6 MO</a:t>
+            </a:r>
+            <a:endParaRPr lang="en-US" sz="1500" dirty="0"/>
+          </a:p>
+        </p:txBody>
+      </p:sp>
+      <p:sp>
+        <p:nvSpPr>
+          <p:cNvPr id="13" name="Text 11"/>
+          <p:cNvSpPr/>
+          <p:nvPr/>
+        </p:nvSpPr>
+        <p:spPr>
+          <a:xfrm>
+            <a:off x="6492240" y="3383280"/>
+            <a:ext cx="2514600" cy="1463040"/>
+          </a:xfrm>
+          <a:prstGeom prst="rect">
+            <a:avLst/>
+          </a:prstGeom>
+          <a:noFill/>
+          <a:ln/>
+        </p:spPr>
+        <p:txBody>
+          <a:bodyPr wrap="square" lIns="0" tIns="0" rIns="0" bIns="0" rtlCol="0" anchor="ctr"/>
+          <a:lstStyle/>
+          <a:p>
+            <a:pPr indent="0" marL="0">
+              <a:lnSpc>
+                <a:spcPts val="1800"/>
+              </a:lnSpc>
+              <a:buNone/>
+            </a:pPr>
+            <a:r>
+              <a:rPr lang="en-US" sz="1350" dirty="0">
+                <a:solidFill>
+                  <a:srgbClr val="5C6E7A"/>
+                </a:solidFill>
+                <a:latin typeface="Arial" pitchFamily="34" charset="0"/>
+                <a:ea typeface="Arial" pitchFamily="34" charset="-122"/>
+                <a:cs typeface="Arial" pitchFamily="34" charset="-120"/>
+              </a:rPr>
+              <a:t>Cloud fleet — managed memory &amp; traces, GPU voice mentors, 24/7 uptime.</a:t>
+            </a:r>
+            <a:endParaRPr lang="en-US" sz="1350" dirty="0"/>
+          </a:p>
+        </p:txBody>
+      </p:sp>
+      <p:sp>
+        <p:nvSpPr>
+          <p:cNvPr id="14" name="Shape 12"/>
+          <p:cNvSpPr/>
+          <p:nvPr/>
+        </p:nvSpPr>
+        <p:spPr>
+          <a:xfrm>
+            <a:off x="9235440" y="2944368"/>
+            <a:ext cx="237744" cy="237744"/>
           </a:xfrm>
           <a:prstGeom prst="ellipse">
             <a:avLst/>
           </a:prstGeom>
           <a:solidFill>
-            <a:srgbClr val="7FC4C9"/>
+            <a:srgbClr val="0B5D66"/>
           </a:solidFill>
           <a:ln/>
         </p:spPr>
       </p:sp>
       <p:sp>
         <p:nvSpPr>
-          <p:cNvPr id="13" name="Shape 11"/>
-          <p:cNvSpPr/>
-          <p:nvPr/>
-        </p:nvSpPr>
-        <p:spPr>
-          <a:xfrm>
-            <a:off x="11336622" y="4524415"/>
-            <a:ext cx="100584" cy="100584"/>
-          </a:xfrm>
-          <a:prstGeom prst="ellipse">
+          <p:cNvPr id="15" name="Text 13"/>
+          <p:cNvSpPr/>
+          <p:nvPr/>
+        </p:nvSpPr>
+        <p:spPr>
+          <a:xfrm>
+            <a:off x="9281160" y="2468880"/>
+            <a:ext cx="2377440" cy="320040"/>
+          </a:xfrm>
+          <a:prstGeom prst="rect">
+            <a:avLst/>
+          </a:prstGeom>
+          <a:noFill/>
+          <a:ln/>
+        </p:spPr>
+        <p:txBody>
+          <a:bodyPr wrap="square" lIns="0" tIns="0" rIns="0" bIns="0" rtlCol="0" anchor="ctr"/>
+          <a:lstStyle/>
+          <a:p>
+            <a:pPr indent="0" marL="0">
+              <a:buNone/>
+            </a:pPr>
+            <a:r>
+              <a:rPr lang="en-US" sz="1500" b="1" spc="100" kern="0" dirty="0">
+                <a:solidFill>
+                  <a:srgbClr val="083F45"/>
+                </a:solidFill>
+                <a:latin typeface="Arial" pitchFamily="34" charset="0"/>
+                <a:ea typeface="Arial" pitchFamily="34" charset="-122"/>
+                <a:cs typeface="Arial" pitchFamily="34" charset="-120"/>
+              </a:rPr>
+              <a:t>+12 MO</a:t>
+            </a:r>
+            <a:endParaRPr lang="en-US" sz="1500" dirty="0"/>
+          </a:p>
+        </p:txBody>
+      </p:sp>
+      <p:sp>
+        <p:nvSpPr>
+          <p:cNvPr id="16" name="Text 14"/>
+          <p:cNvSpPr/>
+          <p:nvPr/>
+        </p:nvSpPr>
+        <p:spPr>
+          <a:xfrm>
+            <a:off x="9281160" y="3383280"/>
+            <a:ext cx="2514600" cy="1463040"/>
+          </a:xfrm>
+          <a:prstGeom prst="rect">
+            <a:avLst/>
+          </a:prstGeom>
+          <a:noFill/>
+          <a:ln/>
+        </p:spPr>
+        <p:txBody>
+          <a:bodyPr wrap="square" lIns="0" tIns="0" rIns="0" bIns="0" rtlCol="0" anchor="ctr"/>
+          <a:lstStyle/>
+          <a:p>
+            <a:pPr indent="0" marL="0">
+              <a:lnSpc>
+                <a:spcPts val="1800"/>
+              </a:lnSpc>
+              <a:buNone/>
+            </a:pPr>
+            <a:r>
+              <a:rPr lang="en-US" sz="1350" dirty="0">
+                <a:solidFill>
+                  <a:srgbClr val="5C6E7A"/>
+                </a:solidFill>
+                <a:latin typeface="Arial" pitchFamily="34" charset="0"/>
+                <a:ea typeface="Arial" pitchFamily="34" charset="-122"/>
+                <a:cs typeface="Arial" pitchFamily="34" charset="-120"/>
+              </a:rPr>
+              <a:t>Governed copilots beyond gaming — agents you can audit, as a category.</a:t>
+            </a:r>
+            <a:endParaRPr lang="en-US" sz="1350" dirty="0"/>
+          </a:p>
+        </p:txBody>
+      </p:sp>
+      <p:sp>
+        <p:nvSpPr>
+          <p:cNvPr id="17" name="Shape 15"/>
+          <p:cNvSpPr/>
+          <p:nvPr/>
+        </p:nvSpPr>
+        <p:spPr>
+          <a:xfrm>
+            <a:off x="0" y="5257800"/>
+            <a:ext cx="12188952" cy="914400"/>
+          </a:xfrm>
+          <a:prstGeom prst="rect">
             <a:avLst/>
           </a:prstGeom>
           <a:solidFill>
-            <a:srgbClr val="7FC4C9"/>
+            <a:srgbClr val="E7F1F1"/>
           </a:solidFill>
           <a:ln/>
         </p:spPr>
       </p:sp>
       <p:sp>
         <p:nvSpPr>
-          <p:cNvPr id="14" name="Shape 12"/>
-          <p:cNvSpPr/>
-          <p:nvPr/>
-        </p:nvSpPr>
-        <p:spPr>
-          <a:xfrm>
-            <a:off x="10222992" y="5010912"/>
-            <a:ext cx="219456" cy="219456"/>
-          </a:xfrm>
-          <a:prstGeom prst="ellipse">
-            <a:avLst/>
-          </a:prstGeom>
-          <a:solidFill>
-            <a:srgbClr val="D97706"/>
-          </a:solidFill>
-          <a:ln/>
-        </p:spPr>
-      </p:sp>
-      <p:sp>
-        <p:nvSpPr>
-          <p:cNvPr id="15" name="Text 13"/>
-          <p:cNvSpPr/>
-          <p:nvPr/>
-        </p:nvSpPr>
-        <p:spPr>
-          <a:xfrm>
-            <a:off x="640080" y="822960"/>
-            <a:ext cx="6400800" cy="320040"/>
-          </a:xfrm>
-          <a:prstGeom prst="rect">
-            <a:avLst/>
-          </a:prstGeom>
-          <a:noFill/>
-          <a:ln/>
-        </p:spPr>
-        <p:txBody>
-          <a:bodyPr wrap="square" lIns="0" tIns="0" rIns="0" bIns="0" rtlCol="0" anchor="ctr"/>
-          <a:lstStyle/>
-          <a:p>
-            <a:pPr indent="0" marL="0">
-              <a:buNone/>
-            </a:pPr>
-            <a:r>
-              <a:rPr lang="en-US" sz="1300" b="1" spc="400" kern="0" dirty="0">
-                <a:solidFill>
-                  <a:srgbClr val="D97706"/>
-                </a:solidFill>
-                <a:latin typeface="Arial" pitchFamily="34" charset="0"/>
-                <a:ea typeface="Arial" pitchFamily="34" charset="-122"/>
-                <a:cs typeface="Arial" pitchFamily="34" charset="-120"/>
-              </a:rPr>
-              <a:t>TEAM &amp; CONTACT</a:t>
-            </a:r>
-            <a:endParaRPr lang="en-US" sz="1300" dirty="0"/>
-          </a:p>
-        </p:txBody>
-      </p:sp>
-      <p:sp>
-        <p:nvSpPr>
-          <p:cNvPr id="16" name="Text 14"/>
-          <p:cNvSpPr/>
-          <p:nvPr/>
-        </p:nvSpPr>
-        <p:spPr>
-          <a:xfrm>
-            <a:off x="640080" y="1371600"/>
-            <a:ext cx="8229600" cy="868680"/>
-          </a:xfrm>
-          <a:prstGeom prst="rect">
-            <a:avLst/>
-          </a:prstGeom>
-          <a:noFill/>
-          <a:ln/>
-        </p:spPr>
-        <p:txBody>
-          <a:bodyPr wrap="square" lIns="0" tIns="0" rIns="0" bIns="0" rtlCol="0" anchor="ctr"/>
-          <a:lstStyle/>
-          <a:p>
-            <a:pPr indent="0" marL="0">
-              <a:buNone/>
-            </a:pPr>
-            <a:r>
-              <a:rPr lang="en-US" sz="4400" b="1" dirty="0">
-                <a:solidFill>
-                  <a:srgbClr val="FFFFFF"/>
-                </a:solidFill>
-                <a:latin typeface="Arial" pitchFamily="34" charset="0"/>
-                <a:ea typeface="Arial" pitchFamily="34" charset="-122"/>
-                <a:cs typeface="Arial" pitchFamily="34" charset="-120"/>
-              </a:rPr>
-              <a:t>Valentin Kalinin</a:t>
-            </a:r>
-            <a:endParaRPr lang="en-US" sz="4400" dirty="0"/>
-          </a:p>
-        </p:txBody>
-      </p:sp>
-      <p:sp>
-        <p:nvSpPr>
-          <p:cNvPr id="17" name="Text 15"/>
-          <p:cNvSpPr/>
-          <p:nvPr/>
-        </p:nvSpPr>
-        <p:spPr>
-          <a:xfrm>
-            <a:off x="640080" y="2331720"/>
-            <a:ext cx="7863840" cy="685800"/>
-          </a:xfrm>
-          <a:prstGeom prst="rect">
-            <a:avLst/>
-          </a:prstGeom>
-          <a:noFill/>
-          <a:ln/>
-        </p:spPr>
-        <p:txBody>
-          <a:bodyPr wrap="square" lIns="0" tIns="0" rIns="0" bIns="0" rtlCol="0" anchor="ctr"/>
-          <a:lstStyle/>
-          <a:p>
-            <a:pPr indent="0" marL="0">
-              <a:lnSpc>
-                <a:spcPts val="2200"/>
-              </a:lnSpc>
-              <a:buNone/>
-            </a:pPr>
-            <a:r>
-              <a:rPr lang="en-US" sz="1600" dirty="0">
-                <a:solidFill>
-                  <a:srgbClr val="C6D4DA"/>
-                </a:solidFill>
-                <a:latin typeface="Arial" pitchFamily="34" charset="0"/>
-                <a:ea typeface="Arial" pitchFamily="34" charset="-122"/>
-                <a:cs typeface="Arial" pitchFamily="34" charset="-120"/>
-              </a:rPr>
-              <a:t>Founder — built the whole stack solo: cognition runtime, Society Protocol, mentor fleet, Dota 2 Copilot.</a:t>
-            </a:r>
-            <a:endParaRPr lang="en-US" sz="1600" dirty="0"/>
-          </a:p>
-        </p:txBody>
-      </p:sp>
-      <p:sp>
-        <p:nvSpPr>
-          <p:cNvPr id="18" name="Shape 16"/>
-          <p:cNvSpPr/>
-          <p:nvPr/>
-        </p:nvSpPr>
-        <p:spPr>
-          <a:xfrm>
-            <a:off x="640080" y="3429000"/>
-            <a:ext cx="7863840" cy="0"/>
-          </a:xfrm>
-          <a:prstGeom prst="line">
-            <a:avLst/>
-          </a:prstGeom>
-          <a:noFill/>
-          <a:ln w="12700">
-            <a:solidFill>
-              <a:srgbClr val="27414E"/>
-            </a:solidFill>
-            <a:prstDash val="solid"/>
-          </a:ln>
-        </p:spPr>
-      </p:sp>
-      <p:sp>
-        <p:nvSpPr>
-          <p:cNvPr id="19" name="Text 17"/>
-          <p:cNvSpPr/>
-          <p:nvPr/>
-        </p:nvSpPr>
-        <p:spPr>
-          <a:xfrm>
-            <a:off x="640080" y="3657600"/>
-            <a:ext cx="7863840" cy="457200"/>
-          </a:xfrm>
-          <a:prstGeom prst="rect">
-            <a:avLst/>
-          </a:prstGeom>
-          <a:noFill/>
-          <a:ln/>
-        </p:spPr>
-        <p:txBody>
-          <a:bodyPr wrap="square" lIns="0" tIns="0" rIns="0" bIns="0" rtlCol="0" anchor="ctr"/>
-          <a:lstStyle/>
-          <a:p>
-            <a:pPr indent="0" marL="0">
-              <a:buNone/>
-            </a:pPr>
-            <a:r>
-              <a:rPr lang="en-US" sz="2400" b="1" dirty="0">
-                <a:solidFill>
-                  <a:srgbClr val="D97706"/>
-                </a:solidFill>
-                <a:latin typeface="Arial" pitchFamily="34" charset="0"/>
-                <a:ea typeface="Arial" pitchFamily="34" charset="-122"/>
-                <a:cs typeface="Arial" pitchFamily="34" charset="-120"/>
-              </a:rPr>
-              <a:t>valentin@mind.glass</a:t>
-            </a:r>
-            <a:endParaRPr lang="en-US" sz="2400" dirty="0"/>
-          </a:p>
-        </p:txBody>
-      </p:sp>
-      <p:sp>
-        <p:nvSpPr>
-          <p:cNvPr id="20" name="Text 18"/>
-          <p:cNvSpPr/>
-          <p:nvPr/>
-        </p:nvSpPr>
-        <p:spPr>
-          <a:xfrm>
-            <a:off x="640080" y="4224528"/>
-            <a:ext cx="7863840" cy="457200"/>
-          </a:xfrm>
-          <a:prstGeom prst="rect">
-            <a:avLst/>
-          </a:prstGeom>
-          <a:noFill/>
-          <a:ln/>
-        </p:spPr>
-        <p:txBody>
-          <a:bodyPr wrap="square" lIns="0" tIns="0" rIns="0" bIns="0" rtlCol="0" anchor="ctr"/>
-          <a:lstStyle/>
-          <a:p>
-            <a:pPr indent="0" marL="0">
-              <a:buNone/>
-            </a:pPr>
-            <a:r>
-              <a:rPr lang="en-US" sz="1800" dirty="0">
-                <a:solidFill>
-                  <a:srgbClr val="C6D4DA"/>
-                </a:solidFill>
-                <a:latin typeface="Arial" pitchFamily="34" charset="0"/>
-                <a:ea typeface="Arial" pitchFamily="34" charset="-122"/>
-                <a:cs typeface="Arial" pitchFamily="34" charset="-120"/>
-              </a:rPr>
-              <a:t>github.com/tdesc/colony-ai-deck</a:t>
-            </a:r>
-            <a:endParaRPr lang="en-US" sz="1800" dirty="0"/>
-          </a:p>
-        </p:txBody>
-      </p:sp>
-      <p:sp>
-        <p:nvSpPr>
-          <p:cNvPr id="21" name="Text 19"/>
-          <p:cNvSpPr/>
-          <p:nvPr/>
-        </p:nvSpPr>
-        <p:spPr>
-          <a:xfrm>
-            <a:off x="640080" y="4791456"/>
-            <a:ext cx="7863840" cy="457200"/>
-          </a:xfrm>
-          <a:prstGeom prst="rect">
-            <a:avLst/>
-          </a:prstGeom>
-          <a:noFill/>
-          <a:ln/>
-        </p:spPr>
-        <p:txBody>
-          <a:bodyPr wrap="square" lIns="0" tIns="0" rIns="0" bIns="0" rtlCol="0" anchor="ctr"/>
-          <a:lstStyle/>
-          <a:p>
-            <a:pPr indent="0" marL="0">
-              <a:buNone/>
-            </a:pPr>
-            <a:r>
-              <a:rPr lang="en-US" sz="1800" dirty="0">
-                <a:solidFill>
-                  <a:srgbClr val="C6D4DA"/>
-                </a:solidFill>
-                <a:latin typeface="Arial" pitchFamily="34" charset="0"/>
-                <a:ea typeface="Arial" pitchFamily="34" charset="-122"/>
-                <a:cs typeface="Arial" pitchFamily="34" charset="-120"/>
-              </a:rPr>
-              <a:t>mind.glass  ·  Saint Petersburg, Russia</a:t>
-            </a:r>
-            <a:endParaRPr lang="en-US" sz="1800" dirty="0"/>
-          </a:p>
-        </p:txBody>
-      </p:sp>
-      <p:sp>
-        <p:nvSpPr>
-          <p:cNvPr id="22" name="Shape 20"/>
-          <p:cNvSpPr/>
-          <p:nvPr/>
-        </p:nvSpPr>
-        <p:spPr>
-          <a:xfrm>
-            <a:off x="640080" y="5806440"/>
-            <a:ext cx="5852160" cy="329184"/>
-          </a:xfrm>
-          <a:prstGeom prst="roundRect">
-            <a:avLst>
-              <a:gd name="adj" fmla="val 50000"/>
-            </a:avLst>
-          </a:prstGeom>
-          <a:solidFill>
-            <a:srgbClr val="0D1B24"/>
-          </a:solidFill>
-          <a:ln w="12700">
-            <a:solidFill>
-              <a:srgbClr val="D97706"/>
-            </a:solidFill>
-            <a:prstDash val="solid"/>
-          </a:ln>
-        </p:spPr>
-      </p:sp>
-      <p:sp>
-        <p:nvSpPr>
-          <p:cNvPr id="23" name="Text 21"/>
-          <p:cNvSpPr/>
-          <p:nvPr/>
-        </p:nvSpPr>
-        <p:spPr>
-          <a:xfrm>
-            <a:off x="640080" y="5806440"/>
-            <a:ext cx="5852160" cy="329184"/>
-          </a:xfrm>
-          <a:prstGeom prst="rect">
-            <a:avLst/>
-          </a:prstGeom>
-          <a:noFill/>
-          <a:ln/>
-        </p:spPr>
-        <p:txBody>
-          <a:bodyPr wrap="square" lIns="0" tIns="0" rIns="0" bIns="0" rtlCol="0" anchor="ctr"/>
-          <a:lstStyle/>
-          <a:p>
-            <a:pPr algn="ctr" indent="0" marL="0">
-              <a:buNone/>
-            </a:pPr>
-            <a:r>
-              <a:rPr lang="en-US" sz="1200" b="1" spc="100" kern="0" dirty="0">
-                <a:solidFill>
-                  <a:srgbClr val="D97706"/>
-                </a:solidFill>
-                <a:latin typeface="Arial" pitchFamily="34" charset="0"/>
-                <a:ea typeface="Arial" pitchFamily="34" charset="-122"/>
-                <a:cs typeface="Arial" pitchFamily="34" charset="-120"/>
-              </a:rPr>
-              <a:t>RECEIPT · SELF-FUNDED WORKING PROTOTYPE · OCT 2026</a:t>
-            </a:r>
-            <a:endParaRPr lang="en-US" sz="1200" dirty="0"/>
-          </a:p>
-        </p:txBody>
-      </p:sp>
-      <p:sp>
-        <p:nvSpPr>
-          <p:cNvPr id="24" name="Text 22"/>
-          <p:cNvSpPr/>
-          <p:nvPr/>
-        </p:nvSpPr>
-        <p:spPr>
-          <a:xfrm>
-            <a:off x="640080" y="6355080"/>
-            <a:ext cx="7315200" cy="320040"/>
-          </a:xfrm>
-          <a:prstGeom prst="rect">
-            <a:avLst/>
-          </a:prstGeom>
-          <a:noFill/>
-          <a:ln/>
-        </p:spPr>
-        <p:txBody>
-          <a:bodyPr wrap="square" lIns="0" tIns="0" rIns="0" bIns="0" rtlCol="0" anchor="ctr"/>
-          <a:lstStyle/>
-          <a:p>
-            <a:pPr indent="0" marL="0">
-              <a:buNone/>
-            </a:pPr>
-            <a:r>
-              <a:rPr lang="en-US" sz="1300" dirty="0">
-                <a:solidFill>
-                  <a:srgbClr val="8FA6B0"/>
-                </a:solidFill>
-                <a:latin typeface="Arial" pitchFamily="34" charset="0"/>
-                <a:ea typeface="Arial" pitchFamily="34" charset="-122"/>
-                <a:cs typeface="Arial" pitchFamily="34" charset="-120"/>
-              </a:rPr>
-              <a:t>Colony AI — Mentor as a Service</a:t>
-            </a:r>
-            <a:endParaRPr lang="en-US" sz="1300" dirty="0"/>
+          <p:cNvPr id="18" name="Text 16"/>
+          <p:cNvSpPr/>
+          <p:nvPr/>
+        </p:nvSpPr>
+        <p:spPr>
+          <a:xfrm>
+            <a:off x="822960" y="5257800"/>
+            <a:ext cx="10607040" cy="914400"/>
+          </a:xfrm>
+          <a:prstGeom prst="rect">
+            <a:avLst/>
+          </a:prstGeom>
+          <a:noFill/>
+          <a:ln/>
+        </p:spPr>
+        <p:txBody>
+          <a:bodyPr wrap="square" lIns="0" tIns="0" rIns="0" bIns="0" rtlCol="0" anchor="ctr"/>
+          <a:lstStyle/>
+          <a:p>
+            <a:pPr indent="0" marL="0">
+              <a:buNone/>
+            </a:pPr>
+            <a:r>
+              <a:rPr lang="en-US" sz="1400" b="1" dirty="0">
+                <a:solidFill>
+                  <a:srgbClr val="083F45"/>
+                </a:solidFill>
+                <a:latin typeface="Arial" pitchFamily="34" charset="0"/>
+                <a:ea typeface="Arial" pitchFamily="34" charset="-122"/>
+                <a:cs typeface="Arial" pitchFamily="34" charset="-120"/>
+              </a:rPr>
+              <a:t>Honest baseline: </a:t>
+            </a:r>
+            <a:pPr indent="0" marL="0">
+              <a:buNone/>
+            </a:pPr>
+            <a:r>
+              <a:rPr lang="en-US" sz="1400" dirty="0">
+                <a:solidFill>
+                  <a:srgbClr val="17242C"/>
+                </a:solidFill>
+                <a:latin typeface="Arial" pitchFamily="34" charset="0"/>
+                <a:ea typeface="Arial" pitchFamily="34" charset="-122"/>
+                <a:cs typeface="Arial" pitchFamily="34" charset="-120"/>
+              </a:rPr>
+              <a:t>no users and no revenue yet. This deck sells a working prototype with live infrastructure — the roadmap is a plan, not a projection.</a:t>
+            </a:r>
+            <a:endParaRPr lang="en-US" sz="1400" dirty="0"/>
           </a:p>
         </p:txBody>
       </p:sp>

</xml_diff>